<commit_message>
Ajuste en reportes excel, mejoras en powerpoint
</commit_message>
<xml_diff>
--- a/storage/templates/Dgdg Mesas de paz.pptx
+++ b/storage/templates/Dgdg Mesas de paz.pptx
@@ -6,29 +6,30 @@
   </p:sldMasterIdLst>
   <p:sldIdLst>
     <p:sldId id="256" r:id="rId2"/>
-    <p:sldId id="257" r:id="rId3"/>
+    <p:sldId id="262" r:id="rId3"/>
     <p:sldId id="258" r:id="rId4"/>
-    <p:sldId id="259" r:id="rId5"/>
-    <p:sldId id="260" r:id="rId6"/>
-    <p:sldId id="261" r:id="rId7"/>
+    <p:sldId id="257" r:id="rId5"/>
+    <p:sldId id="259" r:id="rId6"/>
+    <p:sldId id="260" r:id="rId7"/>
+    <p:sldId id="261" r:id="rId8"/>
   </p:sldIdLst>
   <p:sldSz cx="13716000" cy="10287000"/>
   <p:notesSz cx="6858000" cy="9144000"/>
   <p:embeddedFontLst>
     <p:embeddedFont>
       <p:font typeface="Calibri" panose="020F0502020204030204" pitchFamily="34" charset="0"/>
-      <p:regular r:id="rId8"/>
-      <p:bold r:id="rId9"/>
-      <p:italic r:id="rId10"/>
-      <p:boldItalic r:id="rId11"/>
+      <p:regular r:id="rId9"/>
+      <p:bold r:id="rId10"/>
+      <p:italic r:id="rId11"/>
+      <p:boldItalic r:id="rId12"/>
     </p:embeddedFont>
     <p:embeddedFont>
       <p:font typeface="Gilroy" panose="020B0604020202020204" charset="0"/>
-      <p:regular r:id="rId12"/>
+      <p:regular r:id="rId13"/>
     </p:embeddedFont>
     <p:embeddedFont>
       <p:font typeface="Gilroy Bold" panose="020B0604020202020204" charset="0"/>
-      <p:regular r:id="rId13"/>
+      <p:regular r:id="rId14"/>
     </p:embeddedFont>
   </p:embeddedFontLst>
   <p:defaultTextStyle>
@@ -325,7 +326,7 @@
             <a:fld id="{1D8BD707-D9CF-40AE-B4C6-C98DA3205C09}" type="datetimeFigureOut">
               <a:rPr lang="en-US" smtClean="0"/>
               <a:pPr/>
-              <a:t>3/5/2026</a:t>
+              <a:t>3/6/2026</a:t>
             </a:fld>
             <a:endParaRPr lang="en-US"/>
           </a:p>
@@ -490,7 +491,7 @@
             <a:fld id="{1D8BD707-D9CF-40AE-B4C6-C98DA3205C09}" type="datetimeFigureOut">
               <a:rPr lang="en-US" smtClean="0"/>
               <a:pPr/>
-              <a:t>3/5/2026</a:t>
+              <a:t>3/6/2026</a:t>
             </a:fld>
             <a:endParaRPr lang="en-US"/>
           </a:p>
@@ -665,7 +666,7 @@
             <a:fld id="{1D8BD707-D9CF-40AE-B4C6-C98DA3205C09}" type="datetimeFigureOut">
               <a:rPr lang="en-US" smtClean="0"/>
               <a:pPr/>
-              <a:t>3/5/2026</a:t>
+              <a:t>3/6/2026</a:t>
             </a:fld>
             <a:endParaRPr lang="en-US"/>
           </a:p>
@@ -830,7 +831,7 @@
             <a:fld id="{1D8BD707-D9CF-40AE-B4C6-C98DA3205C09}" type="datetimeFigureOut">
               <a:rPr lang="en-US" smtClean="0"/>
               <a:pPr/>
-              <a:t>3/5/2026</a:t>
+              <a:t>3/6/2026</a:t>
             </a:fld>
             <a:endParaRPr lang="en-US"/>
           </a:p>
@@ -1072,7 +1073,7 @@
             <a:fld id="{1D8BD707-D9CF-40AE-B4C6-C98DA3205C09}" type="datetimeFigureOut">
               <a:rPr lang="en-US" smtClean="0"/>
               <a:pPr/>
-              <a:t>3/5/2026</a:t>
+              <a:t>3/6/2026</a:t>
             </a:fld>
             <a:endParaRPr lang="en-US"/>
           </a:p>
@@ -1354,7 +1355,7 @@
             <a:fld id="{1D8BD707-D9CF-40AE-B4C6-C98DA3205C09}" type="datetimeFigureOut">
               <a:rPr lang="en-US" smtClean="0"/>
               <a:pPr/>
-              <a:t>3/5/2026</a:t>
+              <a:t>3/6/2026</a:t>
             </a:fld>
             <a:endParaRPr lang="en-US"/>
           </a:p>
@@ -1770,7 +1771,7 @@
             <a:fld id="{1D8BD707-D9CF-40AE-B4C6-C98DA3205C09}" type="datetimeFigureOut">
               <a:rPr lang="en-US" smtClean="0"/>
               <a:pPr/>
-              <a:t>3/5/2026</a:t>
+              <a:t>3/6/2026</a:t>
             </a:fld>
             <a:endParaRPr lang="en-US"/>
           </a:p>
@@ -1884,7 +1885,7 @@
             <a:fld id="{1D8BD707-D9CF-40AE-B4C6-C98DA3205C09}" type="datetimeFigureOut">
               <a:rPr lang="en-US" smtClean="0"/>
               <a:pPr/>
-              <a:t>3/5/2026</a:t>
+              <a:t>3/6/2026</a:t>
             </a:fld>
             <a:endParaRPr lang="en-US"/>
           </a:p>
@@ -1976,7 +1977,7 @@
             <a:fld id="{1D8BD707-D9CF-40AE-B4C6-C98DA3205C09}" type="datetimeFigureOut">
               <a:rPr lang="en-US" smtClean="0"/>
               <a:pPr/>
-              <a:t>3/5/2026</a:t>
+              <a:t>3/6/2026</a:t>
             </a:fld>
             <a:endParaRPr lang="en-US"/>
           </a:p>
@@ -2248,7 +2249,7 @@
             <a:fld id="{1D8BD707-D9CF-40AE-B4C6-C98DA3205C09}" type="datetimeFigureOut">
               <a:rPr lang="en-US" smtClean="0"/>
               <a:pPr/>
-              <a:t>3/5/2026</a:t>
+              <a:t>3/6/2026</a:t>
             </a:fld>
             <a:endParaRPr lang="en-US"/>
           </a:p>
@@ -2497,7 +2498,7 @@
             <a:fld id="{1D8BD707-D9CF-40AE-B4C6-C98DA3205C09}" type="datetimeFigureOut">
               <a:rPr lang="en-US" smtClean="0"/>
               <a:pPr/>
-              <a:t>3/5/2026</a:t>
+              <a:t>3/6/2026</a:t>
             </a:fld>
             <a:endParaRPr lang="en-US"/>
           </a:p>
@@ -2705,7 +2706,7 @@
             <a:fld id="{1D8BD707-D9CF-40AE-B4C6-C98DA3205C09}" type="datetimeFigureOut">
               <a:rPr lang="en-US" smtClean="0"/>
               <a:pPr/>
-              <a:t>3/5/2026</a:t>
+              <a:t>3/6/2026</a:t>
             </a:fld>
             <a:endParaRPr lang="en-US"/>
           </a:p>
@@ -3222,7 +3223,7 @@
         </p:nvSpPr>
         <p:spPr>
           <a:xfrm>
-            <a:off x="1230407" y="3807211"/>
+            <a:off x="1258983" y="4027489"/>
             <a:ext cx="11255188" cy="1116011"/>
           </a:xfrm>
           <a:prstGeom prst="rect">
@@ -3244,7 +3245,7 @@
               </a:spcBef>
             </a:pPr>
             <a:r>
-              <a:rPr lang="en-US" sz="6617" b="1">
+              <a:rPr lang="en-US" sz="6617" b="1" dirty="0">
                 <a:solidFill>
                   <a:srgbClr val="FFFFFF"/>
                 </a:solidFill>
@@ -3266,15 +3267,15 @@
         </p:nvSpPr>
         <p:spPr>
           <a:xfrm>
-            <a:off x="1230408" y="3157309"/>
-            <a:ext cx="5142421" cy="665054"/>
+            <a:off x="1258983" y="3362435"/>
+            <a:ext cx="9666192" cy="665054"/>
           </a:xfrm>
           <a:prstGeom prst="rect">
             <a:avLst/>
           </a:prstGeom>
         </p:spPr>
         <p:txBody>
-          <a:bodyPr lIns="0" tIns="0" rIns="0" bIns="0" rtlCol="0" anchor="t">
+          <a:bodyPr wrap="square" lIns="0" tIns="0" rIns="0" bIns="0" rtlCol="0" anchor="t">
             <a:spAutoFit/>
           </a:bodyPr>
           <a:lstStyle/>
@@ -3285,7 +3286,7 @@
               </a:lnSpc>
             </a:pPr>
             <a:r>
-              <a:rPr lang="en-US" sz="3971">
+              <a:rPr lang="en-US" sz="3971" dirty="0" err="1">
                 <a:solidFill>
                   <a:srgbClr val="C79C67"/>
                 </a:solidFill>
@@ -3296,6 +3297,15 @@
               </a:rPr>
               <a:t>Fecha</a:t>
             </a:r>
+            <a:endParaRPr lang="en-US" sz="3971" dirty="0">
+              <a:solidFill>
+                <a:srgbClr val="C79C67"/>
+              </a:solidFill>
+              <a:latin typeface="Gilroy"/>
+              <a:ea typeface="Gilroy"/>
+              <a:cs typeface="Gilroy"/>
+              <a:sym typeface="Gilroy"/>
+            </a:endParaRPr>
           </a:p>
         </p:txBody>
       </p:sp>
@@ -3351,7 +3361,7 @@
         </p:nvSpPr>
         <p:spPr>
           <a:xfrm>
-            <a:off x="1668818" y="5057776"/>
+            <a:off x="1697394" y="5278054"/>
             <a:ext cx="9068615" cy="665054"/>
           </a:xfrm>
           <a:prstGeom prst="rect">
@@ -3370,7 +3380,7 @@
               </a:lnSpc>
             </a:pPr>
             <a:r>
-              <a:rPr lang="en-US" sz="3971">
+              <a:rPr lang="en-US" sz="3971" dirty="0" err="1">
                 <a:solidFill>
                   <a:srgbClr val="FFFFFF"/>
                 </a:solidFill>
@@ -3379,8 +3389,41 @@
                 <a:cs typeface="Gilroy"/>
                 <a:sym typeface="Gilroy"/>
               </a:rPr>
-              <a:t>Dirección General de Delegaciones</a:t>
-            </a:r>
+              <a:t>Dirección</a:t>
+            </a:r>
+            <a:r>
+              <a:rPr lang="en-US" sz="3971" dirty="0">
+                <a:solidFill>
+                  <a:srgbClr val="FFFFFF"/>
+                </a:solidFill>
+                <a:latin typeface="Gilroy"/>
+                <a:ea typeface="Gilroy"/>
+                <a:cs typeface="Gilroy"/>
+                <a:sym typeface="Gilroy"/>
+              </a:rPr>
+              <a:t> General de </a:t>
+            </a:r>
+            <a:r>
+              <a:rPr lang="en-US" sz="3971" dirty="0" err="1">
+                <a:solidFill>
+                  <a:srgbClr val="FFFFFF"/>
+                </a:solidFill>
+                <a:latin typeface="Gilroy"/>
+                <a:ea typeface="Gilroy"/>
+                <a:cs typeface="Gilroy"/>
+                <a:sym typeface="Gilroy"/>
+              </a:rPr>
+              <a:t>Delegaciones</a:t>
+            </a:r>
+            <a:endParaRPr lang="en-US" sz="3971" dirty="0">
+              <a:solidFill>
+                <a:srgbClr val="FFFFFF"/>
+              </a:solidFill>
+              <a:latin typeface="Gilroy"/>
+              <a:ea typeface="Gilroy"/>
+              <a:cs typeface="Gilroy"/>
+              <a:sym typeface="Gilroy"/>
+            </a:endParaRPr>
           </a:p>
         </p:txBody>
       </p:sp>
@@ -3393,6 +3436,1250 @@
 </file>
 
 <file path=ppt/slides/slide2.xml><?xml version="1.0" encoding="utf-8"?>
+<p:sld xmlns:a="http://schemas.openxmlformats.org/drawingml/2006/main" xmlns:r="http://schemas.openxmlformats.org/officeDocument/2006/relationships" xmlns:p="http://schemas.openxmlformats.org/presentationml/2006/main">
+  <p:cSld>
+    <p:spTree>
+      <p:nvGrpSpPr>
+        <p:cNvPr id="1" name=""/>
+        <p:cNvGrpSpPr/>
+        <p:nvPr/>
+      </p:nvGrpSpPr>
+      <p:grpSpPr>
+        <a:xfrm>
+          <a:off x="0" y="0"/>
+          <a:ext cx="0" cy="0"/>
+          <a:chOff x="0" y="0"/>
+          <a:chExt cx="0" cy="0"/>
+        </a:xfrm>
+      </p:grpSpPr>
+      <p:sp>
+        <p:nvSpPr>
+          <p:cNvPr id="2" name="Freeform 2"/>
+          <p:cNvSpPr/>
+          <p:nvPr/>
+        </p:nvSpPr>
+        <p:spPr>
+          <a:xfrm>
+            <a:off x="0" y="2"/>
+            <a:ext cx="13715999" cy="10283975"/>
+          </a:xfrm>
+          <a:custGeom>
+            <a:avLst/>
+            <a:gdLst/>
+            <a:ahLst/>
+            <a:cxnLst/>
+            <a:rect l="l" t="t" r="r" b="b"/>
+            <a:pathLst>
+              <a:path w="13312588" h="10283974">
+                <a:moveTo>
+                  <a:pt x="0" y="0"/>
+                </a:moveTo>
+                <a:lnTo>
+                  <a:pt x="13312588" y="0"/>
+                </a:lnTo>
+                <a:lnTo>
+                  <a:pt x="13312588" y="10283974"/>
+                </a:lnTo>
+                <a:lnTo>
+                  <a:pt x="0" y="10283974"/>
+                </a:lnTo>
+                <a:lnTo>
+                  <a:pt x="0" y="0"/>
+                </a:lnTo>
+                <a:close/>
+              </a:path>
+            </a:pathLst>
+          </a:custGeom>
+          <a:blipFill>
+            <a:blip r:embed="rId2"/>
+            <a:stretch>
+              <a:fillRect/>
+            </a:stretch>
+          </a:blipFill>
+        </p:spPr>
+      </p:sp>
+      <p:sp>
+        <p:nvSpPr>
+          <p:cNvPr id="3" name="TextBox 3"/>
+          <p:cNvSpPr txBox="1"/>
+          <p:nvPr/>
+        </p:nvSpPr>
+        <p:spPr>
+          <a:xfrm>
+            <a:off x="1001527" y="1703006"/>
+            <a:ext cx="6477000" cy="1055161"/>
+          </a:xfrm>
+          <a:prstGeom prst="rect">
+            <a:avLst/>
+          </a:prstGeom>
+        </p:spPr>
+        <p:txBody>
+          <a:bodyPr wrap="square" lIns="0" tIns="0" rIns="0" bIns="0" rtlCol="0" anchor="t">
+            <a:spAutoFit/>
+          </a:bodyPr>
+          <a:lstStyle/>
+          <a:p>
+            <a:pPr>
+              <a:lnSpc>
+                <a:spcPts val="9264"/>
+              </a:lnSpc>
+              <a:spcBef>
+                <a:spcPct val="0"/>
+              </a:spcBef>
+            </a:pPr>
+            <a:r>
+              <a:rPr lang="en-US" sz="4400" b="1" dirty="0">
+                <a:latin typeface="Gilroy Bold"/>
+                <a:ea typeface="Gilroy Bold"/>
+                <a:cs typeface="Gilroy Bold"/>
+                <a:sym typeface="Gilroy Bold"/>
+              </a:rPr>
+              <a:t>ORDEN DEL DÍA</a:t>
+            </a:r>
+          </a:p>
+        </p:txBody>
+      </p:sp>
+      <p:sp>
+        <p:nvSpPr>
+          <p:cNvPr id="4" name="Freeform 4"/>
+          <p:cNvSpPr/>
+          <p:nvPr/>
+        </p:nvSpPr>
+        <p:spPr>
+          <a:xfrm>
+            <a:off x="747524" y="477342"/>
+            <a:ext cx="6985007" cy="738799"/>
+          </a:xfrm>
+          <a:custGeom>
+            <a:avLst/>
+            <a:gdLst/>
+            <a:ahLst/>
+            <a:cxnLst/>
+            <a:rect l="l" t="t" r="r" b="b"/>
+            <a:pathLst>
+              <a:path w="6985006" h="738799">
+                <a:moveTo>
+                  <a:pt x="0" y="0"/>
+                </a:moveTo>
+                <a:lnTo>
+                  <a:pt x="6985006" y="0"/>
+                </a:lnTo>
+                <a:lnTo>
+                  <a:pt x="6985006" y="738798"/>
+                </a:lnTo>
+                <a:lnTo>
+                  <a:pt x="0" y="738798"/>
+                </a:lnTo>
+                <a:lnTo>
+                  <a:pt x="0" y="0"/>
+                </a:lnTo>
+                <a:close/>
+              </a:path>
+            </a:pathLst>
+          </a:custGeom>
+          <a:blipFill>
+            <a:blip r:embed="rId3"/>
+            <a:stretch>
+              <a:fillRect/>
+            </a:stretch>
+          </a:blipFill>
+        </p:spPr>
+      </p:sp>
+      <p:sp>
+        <p:nvSpPr>
+          <p:cNvPr id="6" name="TextBox 6"/>
+          <p:cNvSpPr txBox="1"/>
+          <p:nvPr/>
+        </p:nvSpPr>
+        <p:spPr>
+          <a:xfrm>
+            <a:off x="8368701" y="9426304"/>
+            <a:ext cx="4723075" cy="393185"/>
+          </a:xfrm>
+          <a:prstGeom prst="rect">
+            <a:avLst/>
+          </a:prstGeom>
+        </p:spPr>
+        <p:txBody>
+          <a:bodyPr lIns="0" tIns="0" rIns="0" bIns="0" rtlCol="0" anchor="t">
+            <a:spAutoFit/>
+          </a:bodyPr>
+          <a:lstStyle/>
+          <a:p>
+            <a:pPr algn="r">
+              <a:lnSpc>
+                <a:spcPts val="3335"/>
+              </a:lnSpc>
+              <a:spcBef>
+                <a:spcPct val="0"/>
+              </a:spcBef>
+            </a:pPr>
+            <a:r>
+              <a:rPr lang="en-US" sz="2381">
+                <a:solidFill>
+                  <a:srgbClr val="4B4B4B"/>
+                </a:solidFill>
+                <a:latin typeface="Gilroy"/>
+                <a:ea typeface="Gilroy"/>
+                <a:cs typeface="Gilroy"/>
+                <a:sym typeface="Gilroy"/>
+              </a:rPr>
+              <a:t>30 de Febrero del 2026</a:t>
+            </a:r>
+          </a:p>
+        </p:txBody>
+      </p:sp>
+      <p:grpSp>
+        <p:nvGrpSpPr>
+          <p:cNvPr id="7" name="Group 7"/>
+          <p:cNvGrpSpPr/>
+          <p:nvPr/>
+        </p:nvGrpSpPr>
+        <p:grpSpPr>
+          <a:xfrm>
+            <a:off x="747523" y="9670731"/>
+            <a:ext cx="7468012" cy="143471"/>
+            <a:chOff x="0" y="0"/>
+            <a:chExt cx="9957349" cy="191294"/>
+          </a:xfrm>
+        </p:grpSpPr>
+        <p:sp>
+          <p:nvSpPr>
+            <p:cNvPr id="8" name="Freeform 8"/>
+            <p:cNvSpPr/>
+            <p:nvPr/>
+          </p:nvSpPr>
+          <p:spPr>
+            <a:xfrm>
+              <a:off x="0" y="0"/>
+              <a:ext cx="9957349" cy="191294"/>
+            </a:xfrm>
+            <a:custGeom>
+              <a:avLst/>
+              <a:gdLst/>
+              <a:ahLst/>
+              <a:cxnLst/>
+              <a:rect l="l" t="t" r="r" b="b"/>
+              <a:pathLst>
+                <a:path w="9957349" h="191294">
+                  <a:moveTo>
+                    <a:pt x="0" y="0"/>
+                  </a:moveTo>
+                  <a:lnTo>
+                    <a:pt x="9957349" y="0"/>
+                  </a:lnTo>
+                  <a:lnTo>
+                    <a:pt x="9957349" y="191294"/>
+                  </a:lnTo>
+                  <a:lnTo>
+                    <a:pt x="0" y="191294"/>
+                  </a:lnTo>
+                  <a:lnTo>
+                    <a:pt x="0" y="0"/>
+                  </a:lnTo>
+                  <a:close/>
+                </a:path>
+              </a:pathLst>
+            </a:custGeom>
+            <a:blipFill>
+              <a:blip r:embed="rId4"/>
+              <a:stretch>
+                <a:fillRect/>
+              </a:stretch>
+            </a:blipFill>
+          </p:spPr>
+        </p:sp>
+        <p:sp>
+          <p:nvSpPr>
+            <p:cNvPr id="9" name="Freeform 9"/>
+            <p:cNvSpPr/>
+            <p:nvPr/>
+          </p:nvSpPr>
+          <p:spPr>
+            <a:xfrm>
+              <a:off x="0" y="0"/>
+              <a:ext cx="9957349" cy="191294"/>
+            </a:xfrm>
+            <a:custGeom>
+              <a:avLst/>
+              <a:gdLst/>
+              <a:ahLst/>
+              <a:cxnLst/>
+              <a:rect l="l" t="t" r="r" b="b"/>
+              <a:pathLst>
+                <a:path w="9957349" h="191294">
+                  <a:moveTo>
+                    <a:pt x="0" y="0"/>
+                  </a:moveTo>
+                  <a:lnTo>
+                    <a:pt x="9957349" y="0"/>
+                  </a:lnTo>
+                  <a:lnTo>
+                    <a:pt x="9957349" y="191294"/>
+                  </a:lnTo>
+                  <a:lnTo>
+                    <a:pt x="0" y="191294"/>
+                  </a:lnTo>
+                  <a:lnTo>
+                    <a:pt x="0" y="0"/>
+                  </a:lnTo>
+                  <a:close/>
+                </a:path>
+              </a:pathLst>
+            </a:custGeom>
+            <a:blipFill>
+              <a:blip r:embed="rId4"/>
+              <a:stretch>
+                <a:fillRect/>
+              </a:stretch>
+            </a:blipFill>
+          </p:spPr>
+        </p:sp>
+      </p:grpSp>
+      <p:sp>
+        <p:nvSpPr>
+          <p:cNvPr id="10" name="TextBox 5">
+            <a:extLst>
+              <a:ext uri="{FF2B5EF4-FFF2-40B4-BE49-F238E27FC236}">
+                <a16:creationId xmlns:a16="http://schemas.microsoft.com/office/drawing/2014/main" id="{889021D9-83F2-483B-8EA3-0C079360380B}"/>
+              </a:ext>
+            </a:extLst>
+          </p:cNvPr>
+          <p:cNvSpPr txBox="1"/>
+          <p:nvPr/>
+        </p:nvSpPr>
+        <p:spPr>
+          <a:xfrm>
+            <a:off x="1719962" y="3543300"/>
+            <a:ext cx="10276073" cy="2819490"/>
+          </a:xfrm>
+          <a:prstGeom prst="rect">
+            <a:avLst/>
+          </a:prstGeom>
+        </p:spPr>
+        <p:txBody>
+          <a:bodyPr wrap="square" lIns="0" tIns="0" rIns="0" bIns="0" rtlCol="0" anchor="t">
+            <a:spAutoFit/>
+          </a:bodyPr>
+          <a:lstStyle/>
+          <a:p>
+            <a:pPr marL="742950" indent="-742950">
+              <a:lnSpc>
+                <a:spcPts val="5559"/>
+              </a:lnSpc>
+              <a:buFont typeface="+mj-lt"/>
+              <a:buAutoNum type="arabicPeriod"/>
+            </a:pPr>
+            <a:r>
+              <a:rPr lang="en-US" sz="3971" dirty="0" err="1">
+                <a:latin typeface="Gilroy"/>
+                <a:ea typeface="Gilroy"/>
+                <a:cs typeface="Gilroy"/>
+                <a:sym typeface="Gilroy"/>
+              </a:rPr>
+              <a:t>Reporte</a:t>
+            </a:r>
+            <a:r>
+              <a:rPr lang="en-US" sz="3971" dirty="0">
+                <a:latin typeface="Gilroy"/>
+                <a:ea typeface="Gilroy"/>
+                <a:cs typeface="Gilroy"/>
+                <a:sym typeface="Gilroy"/>
+              </a:rPr>
+              <a:t> General.</a:t>
+            </a:r>
+          </a:p>
+          <a:p>
+            <a:pPr marL="742950" indent="-742950">
+              <a:lnSpc>
+                <a:spcPts val="5559"/>
+              </a:lnSpc>
+              <a:buFont typeface="+mj-lt"/>
+              <a:buAutoNum type="arabicPeriod"/>
+            </a:pPr>
+            <a:r>
+              <a:rPr lang="en-US" sz="3971" dirty="0" err="1">
+                <a:latin typeface="Gilroy"/>
+                <a:ea typeface="Gilroy"/>
+                <a:cs typeface="Gilroy"/>
+                <a:sym typeface="Gilroy"/>
+              </a:rPr>
+              <a:t>Reporte</a:t>
+            </a:r>
+            <a:r>
+              <a:rPr lang="en-US" sz="3971" dirty="0">
+                <a:latin typeface="Gilroy"/>
+                <a:ea typeface="Gilroy"/>
+                <a:cs typeface="Gilroy"/>
+                <a:sym typeface="Gilroy"/>
+              </a:rPr>
+              <a:t> </a:t>
+            </a:r>
+            <a:r>
+              <a:rPr lang="en-US" sz="3971" dirty="0" err="1">
+                <a:latin typeface="Gilroy"/>
+                <a:ea typeface="Gilroy"/>
+                <a:cs typeface="Gilroy"/>
+                <a:sym typeface="Gilroy"/>
+              </a:rPr>
+              <a:t>Diario</a:t>
+            </a:r>
+            <a:r>
+              <a:rPr lang="en-US" sz="3971" dirty="0">
+                <a:latin typeface="Gilroy"/>
+                <a:ea typeface="Gilroy"/>
+                <a:cs typeface="Gilroy"/>
+                <a:sym typeface="Gilroy"/>
+              </a:rPr>
+              <a:t>.</a:t>
+            </a:r>
+          </a:p>
+          <a:p>
+            <a:pPr marL="742950" indent="-742950">
+              <a:lnSpc>
+                <a:spcPts val="5559"/>
+              </a:lnSpc>
+              <a:buFont typeface="+mj-lt"/>
+              <a:buAutoNum type="arabicPeriod"/>
+            </a:pPr>
+            <a:r>
+              <a:rPr lang="en-US" sz="3971" dirty="0" err="1">
+                <a:latin typeface="Gilroy"/>
+                <a:ea typeface="Gilroy"/>
+                <a:cs typeface="Gilroy"/>
+                <a:sym typeface="Gilroy"/>
+              </a:rPr>
+              <a:t>Reporte</a:t>
+            </a:r>
+            <a:r>
+              <a:rPr lang="en-US" sz="3971" dirty="0">
+                <a:latin typeface="Gilroy"/>
+                <a:ea typeface="Gilroy"/>
+                <a:cs typeface="Gilroy"/>
+                <a:sym typeface="Gilroy"/>
+              </a:rPr>
+              <a:t> por </a:t>
+            </a:r>
+            <a:r>
+              <a:rPr lang="en-US" sz="3971" dirty="0" err="1">
+                <a:latin typeface="Gilroy"/>
+                <a:ea typeface="Gilroy"/>
+                <a:cs typeface="Gilroy"/>
+                <a:sym typeface="Gilroy"/>
+              </a:rPr>
+              <a:t>Mircorregión</a:t>
+            </a:r>
+            <a:r>
+              <a:rPr lang="en-US" sz="3971" dirty="0">
+                <a:latin typeface="Gilroy"/>
+                <a:ea typeface="Gilroy"/>
+                <a:cs typeface="Gilroy"/>
+                <a:sym typeface="Gilroy"/>
+              </a:rPr>
+              <a:t>.</a:t>
+            </a:r>
+          </a:p>
+          <a:p>
+            <a:pPr marL="742950" indent="-742950">
+              <a:lnSpc>
+                <a:spcPts val="5559"/>
+              </a:lnSpc>
+              <a:buFont typeface="+mj-lt"/>
+              <a:buAutoNum type="arabicPeriod"/>
+            </a:pPr>
+            <a:r>
+              <a:rPr lang="en-US" sz="3971" dirty="0" err="1">
+                <a:latin typeface="Gilroy"/>
+                <a:ea typeface="Gilroy"/>
+                <a:cs typeface="Gilroy"/>
+                <a:sym typeface="Gilroy"/>
+              </a:rPr>
+              <a:t>Reportes</a:t>
+            </a:r>
+            <a:r>
+              <a:rPr lang="en-US" sz="3971" dirty="0">
+                <a:latin typeface="Gilroy"/>
+                <a:ea typeface="Gilroy"/>
+                <a:cs typeface="Gilroy"/>
+                <a:sym typeface="Gilroy"/>
+              </a:rPr>
+              <a:t> </a:t>
+            </a:r>
+            <a:r>
+              <a:rPr lang="en-US" sz="3971" dirty="0" err="1">
+                <a:latin typeface="Gilroy"/>
+                <a:ea typeface="Gilroy"/>
+                <a:cs typeface="Gilroy"/>
+                <a:sym typeface="Gilroy"/>
+              </a:rPr>
+              <a:t>Diarios</a:t>
+            </a:r>
+            <a:r>
+              <a:rPr lang="en-US" sz="3971" dirty="0">
+                <a:latin typeface="Gilroy"/>
+                <a:ea typeface="Gilroy"/>
+                <a:cs typeface="Gilroy"/>
+                <a:sym typeface="Gilroy"/>
+              </a:rPr>
+              <a:t> por </a:t>
+            </a:r>
+            <a:r>
+              <a:rPr lang="en-US" sz="3971" dirty="0" err="1">
+                <a:latin typeface="Gilroy"/>
+                <a:ea typeface="Gilroy"/>
+                <a:cs typeface="Gilroy"/>
+                <a:sym typeface="Gilroy"/>
+              </a:rPr>
+              <a:t>Microrregión</a:t>
+            </a:r>
+            <a:r>
+              <a:rPr lang="en-US" sz="3971" dirty="0">
+                <a:latin typeface="Gilroy"/>
+                <a:ea typeface="Gilroy"/>
+                <a:cs typeface="Gilroy"/>
+                <a:sym typeface="Gilroy"/>
+              </a:rPr>
+              <a:t>.</a:t>
+            </a:r>
+          </a:p>
+        </p:txBody>
+      </p:sp>
+    </p:spTree>
+    <p:extLst>
+      <p:ext uri="{BB962C8B-B14F-4D97-AF65-F5344CB8AC3E}">
+        <p14:creationId xmlns:p14="http://schemas.microsoft.com/office/powerpoint/2010/main" val="3174868268"/>
+      </p:ext>
+    </p:extLst>
+  </p:cSld>
+  <p:clrMapOvr>
+    <a:masterClrMapping/>
+  </p:clrMapOvr>
+</p:sld>
+</file>
+
+<file path=ppt/slides/slide3.xml><?xml version="1.0" encoding="utf-8"?>
+<p:sld xmlns:a="http://schemas.openxmlformats.org/drawingml/2006/main" xmlns:r="http://schemas.openxmlformats.org/officeDocument/2006/relationships" xmlns:p="http://schemas.openxmlformats.org/presentationml/2006/main">
+  <p:cSld>
+    <p:spTree>
+      <p:nvGrpSpPr>
+        <p:cNvPr id="1" name=""/>
+        <p:cNvGrpSpPr/>
+        <p:nvPr/>
+      </p:nvGrpSpPr>
+      <p:grpSpPr>
+        <a:xfrm>
+          <a:off x="0" y="0"/>
+          <a:ext cx="0" cy="0"/>
+          <a:chOff x="0" y="0"/>
+          <a:chExt cx="0" cy="0"/>
+        </a:xfrm>
+      </p:grpSpPr>
+      <p:grpSp>
+        <p:nvGrpSpPr>
+          <p:cNvPr id="2" name="Group 2"/>
+          <p:cNvGrpSpPr/>
+          <p:nvPr/>
+        </p:nvGrpSpPr>
+        <p:grpSpPr>
+          <a:xfrm>
+            <a:off x="-76200" y="3025"/>
+            <a:ext cx="13715999" cy="10283975"/>
+            <a:chOff x="0" y="0"/>
+            <a:chExt cx="17750118" cy="13711966"/>
+          </a:xfrm>
+        </p:grpSpPr>
+        <p:sp>
+          <p:nvSpPr>
+            <p:cNvPr id="3" name="Freeform 3"/>
+            <p:cNvSpPr/>
+            <p:nvPr/>
+          </p:nvSpPr>
+          <p:spPr>
+            <a:xfrm>
+              <a:off x="0" y="0"/>
+              <a:ext cx="17750118" cy="13711966"/>
+            </a:xfrm>
+            <a:custGeom>
+              <a:avLst/>
+              <a:gdLst/>
+              <a:ahLst/>
+              <a:cxnLst/>
+              <a:rect l="l" t="t" r="r" b="b"/>
+              <a:pathLst>
+                <a:path w="17750118" h="13711966">
+                  <a:moveTo>
+                    <a:pt x="0" y="0"/>
+                  </a:moveTo>
+                  <a:lnTo>
+                    <a:pt x="17750118" y="0"/>
+                  </a:lnTo>
+                  <a:lnTo>
+                    <a:pt x="17750118" y="13711966"/>
+                  </a:lnTo>
+                  <a:lnTo>
+                    <a:pt x="0" y="13711966"/>
+                  </a:lnTo>
+                  <a:lnTo>
+                    <a:pt x="0" y="0"/>
+                  </a:lnTo>
+                  <a:close/>
+                </a:path>
+              </a:pathLst>
+            </a:custGeom>
+            <a:blipFill>
+              <a:blip r:embed="rId2"/>
+              <a:stretch>
+                <a:fillRect/>
+              </a:stretch>
+            </a:blipFill>
+          </p:spPr>
+        </p:sp>
+        <p:sp>
+          <p:nvSpPr>
+            <p:cNvPr id="4" name="Freeform 4"/>
+            <p:cNvSpPr/>
+            <p:nvPr/>
+          </p:nvSpPr>
+          <p:spPr>
+            <a:xfrm>
+              <a:off x="777253" y="616144"/>
+              <a:ext cx="9313341" cy="985065"/>
+            </a:xfrm>
+            <a:custGeom>
+              <a:avLst/>
+              <a:gdLst/>
+              <a:ahLst/>
+              <a:cxnLst/>
+              <a:rect l="l" t="t" r="r" b="b"/>
+              <a:pathLst>
+                <a:path w="9313341" h="985065">
+                  <a:moveTo>
+                    <a:pt x="0" y="0"/>
+                  </a:moveTo>
+                  <a:lnTo>
+                    <a:pt x="9313342" y="0"/>
+                  </a:lnTo>
+                  <a:lnTo>
+                    <a:pt x="9313342" y="985065"/>
+                  </a:lnTo>
+                  <a:lnTo>
+                    <a:pt x="0" y="985065"/>
+                  </a:lnTo>
+                  <a:lnTo>
+                    <a:pt x="0" y="0"/>
+                  </a:lnTo>
+                  <a:close/>
+                </a:path>
+              </a:pathLst>
+            </a:custGeom>
+            <a:blipFill>
+              <a:blip r:embed="rId3"/>
+              <a:stretch>
+                <a:fillRect/>
+              </a:stretch>
+            </a:blipFill>
+          </p:spPr>
+        </p:sp>
+        <p:sp>
+          <p:nvSpPr>
+            <p:cNvPr id="5" name="Freeform 5"/>
+            <p:cNvSpPr/>
+            <p:nvPr/>
+          </p:nvSpPr>
+          <p:spPr>
+            <a:xfrm>
+              <a:off x="777253" y="13401347"/>
+              <a:ext cx="16168531" cy="310619"/>
+            </a:xfrm>
+            <a:custGeom>
+              <a:avLst/>
+              <a:gdLst/>
+              <a:ahLst/>
+              <a:cxnLst/>
+              <a:rect l="l" t="t" r="r" b="b"/>
+              <a:pathLst>
+                <a:path w="16168531" h="310619">
+                  <a:moveTo>
+                    <a:pt x="0" y="0"/>
+                  </a:moveTo>
+                  <a:lnTo>
+                    <a:pt x="16168531" y="0"/>
+                  </a:lnTo>
+                  <a:lnTo>
+                    <a:pt x="16168531" y="310619"/>
+                  </a:lnTo>
+                  <a:lnTo>
+                    <a:pt x="0" y="310619"/>
+                  </a:lnTo>
+                  <a:lnTo>
+                    <a:pt x="0" y="0"/>
+                  </a:lnTo>
+                  <a:close/>
+                </a:path>
+              </a:pathLst>
+            </a:custGeom>
+            <a:blipFill>
+              <a:blip r:embed="rId4"/>
+              <a:stretch>
+                <a:fillRect/>
+              </a:stretch>
+            </a:blipFill>
+          </p:spPr>
+        </p:sp>
+      </p:grpSp>
+      <p:sp>
+        <p:nvSpPr>
+          <p:cNvPr id="7" name="TextBox 3">
+            <a:extLst>
+              <a:ext uri="{FF2B5EF4-FFF2-40B4-BE49-F238E27FC236}">
+                <a16:creationId xmlns:a16="http://schemas.microsoft.com/office/drawing/2014/main" id="{DB6A8119-BC10-4878-841C-E446DD6DF07E}"/>
+              </a:ext>
+            </a:extLst>
+          </p:cNvPr>
+          <p:cNvSpPr txBox="1"/>
+          <p:nvPr/>
+        </p:nvSpPr>
+        <p:spPr>
+          <a:xfrm>
+            <a:off x="824652" y="1414738"/>
+            <a:ext cx="4906959" cy="1055161"/>
+          </a:xfrm>
+          <a:prstGeom prst="rect">
+            <a:avLst/>
+          </a:prstGeom>
+        </p:spPr>
+        <p:txBody>
+          <a:bodyPr wrap="square" lIns="0" tIns="0" rIns="0" bIns="0" rtlCol="0" anchor="t">
+            <a:spAutoFit/>
+          </a:bodyPr>
+          <a:lstStyle/>
+          <a:p>
+            <a:pPr>
+              <a:lnSpc>
+                <a:spcPts val="9264"/>
+              </a:lnSpc>
+              <a:spcBef>
+                <a:spcPct val="0"/>
+              </a:spcBef>
+            </a:pPr>
+            <a:r>
+              <a:rPr lang="en-US" sz="4800" b="1" dirty="0" err="1">
+                <a:latin typeface="Gilroy Bold"/>
+                <a:ea typeface="Gilroy Bold"/>
+                <a:cs typeface="Gilroy Bold"/>
+                <a:sym typeface="Gilroy Bold"/>
+              </a:rPr>
+              <a:t>Reporte</a:t>
+            </a:r>
+            <a:r>
+              <a:rPr lang="en-US" sz="4800" b="1" dirty="0">
+                <a:latin typeface="Gilroy Bold"/>
+                <a:ea typeface="Gilroy Bold"/>
+                <a:cs typeface="Gilroy Bold"/>
+                <a:sym typeface="Gilroy Bold"/>
+              </a:rPr>
+              <a:t> General</a:t>
+            </a:r>
+          </a:p>
+        </p:txBody>
+      </p:sp>
+      <p:sp>
+        <p:nvSpPr>
+          <p:cNvPr id="8" name="TextBox 5">
+            <a:extLst>
+              <a:ext uri="{FF2B5EF4-FFF2-40B4-BE49-F238E27FC236}">
+                <a16:creationId xmlns:a16="http://schemas.microsoft.com/office/drawing/2014/main" id="{60957767-D37B-4C63-90C8-BBA01ACAF7F0}"/>
+              </a:ext>
+            </a:extLst>
+          </p:cNvPr>
+          <p:cNvSpPr txBox="1"/>
+          <p:nvPr/>
+        </p:nvSpPr>
+        <p:spPr>
+          <a:xfrm>
+            <a:off x="3278132" y="3376740"/>
+            <a:ext cx="3450619" cy="627736"/>
+          </a:xfrm>
+          <a:prstGeom prst="rect">
+            <a:avLst/>
+          </a:prstGeom>
+        </p:spPr>
+        <p:txBody>
+          <a:bodyPr wrap="square" lIns="0" tIns="0" rIns="0" bIns="0" rtlCol="0" anchor="t">
+            <a:spAutoFit/>
+          </a:bodyPr>
+          <a:lstStyle/>
+          <a:p>
+            <a:pPr>
+              <a:lnSpc>
+                <a:spcPts val="5559"/>
+              </a:lnSpc>
+            </a:pPr>
+            <a:r>
+              <a:rPr lang="en-US" sz="2800" dirty="0">
+                <a:latin typeface="Gilroy" panose="020B0604020202020204" charset="0"/>
+                <a:ea typeface="Gilroy"/>
+                <a:cs typeface="Gilroy"/>
+                <a:sym typeface="Gilroy"/>
+              </a:rPr>
+              <a:t>Mesas de </a:t>
+            </a:r>
+            <a:r>
+              <a:rPr lang="en-US" sz="2800" dirty="0" err="1">
+                <a:latin typeface="Gilroy" panose="020B0604020202020204" charset="0"/>
+                <a:ea typeface="Gilroy"/>
+                <a:cs typeface="Gilroy"/>
+                <a:sym typeface="Gilroy"/>
+              </a:rPr>
+              <a:t>seguridad</a:t>
+            </a:r>
+            <a:endParaRPr lang="en-US" sz="2800" dirty="0">
+              <a:latin typeface="Gilroy" panose="020B0604020202020204" charset="0"/>
+              <a:ea typeface="Gilroy"/>
+              <a:cs typeface="Gilroy"/>
+              <a:sym typeface="Gilroy"/>
+            </a:endParaRPr>
+          </a:p>
+        </p:txBody>
+      </p:sp>
+      <p:sp>
+        <p:nvSpPr>
+          <p:cNvPr id="9" name="TextBox 5">
+            <a:extLst>
+              <a:ext uri="{FF2B5EF4-FFF2-40B4-BE49-F238E27FC236}">
+                <a16:creationId xmlns:a16="http://schemas.microsoft.com/office/drawing/2014/main" id="{96FB21E9-5811-40C0-8235-73AD799DA764}"/>
+              </a:ext>
+            </a:extLst>
+          </p:cNvPr>
+          <p:cNvSpPr txBox="1"/>
+          <p:nvPr/>
+        </p:nvSpPr>
+        <p:spPr>
+          <a:xfrm>
+            <a:off x="1619450" y="5101700"/>
+            <a:ext cx="2107662" cy="627736"/>
+          </a:xfrm>
+          <a:prstGeom prst="rect">
+            <a:avLst/>
+          </a:prstGeom>
+        </p:spPr>
+        <p:txBody>
+          <a:bodyPr wrap="square" lIns="0" tIns="0" rIns="0" bIns="0" rtlCol="0" anchor="t">
+            <a:spAutoFit/>
+          </a:bodyPr>
+          <a:lstStyle/>
+          <a:p>
+            <a:pPr>
+              <a:lnSpc>
+                <a:spcPts val="5559"/>
+              </a:lnSpc>
+            </a:pPr>
+            <a:r>
+              <a:rPr lang="en-US" sz="2800" dirty="0" err="1">
+                <a:latin typeface="Gilroy" panose="020B0604020202020204" charset="0"/>
+                <a:ea typeface="Gilroy"/>
+                <a:cs typeface="Gilroy"/>
+                <a:sym typeface="Gilroy"/>
+              </a:rPr>
+              <a:t>Asistencias</a:t>
+            </a:r>
+            <a:endParaRPr lang="en-US" sz="2800" dirty="0">
+              <a:latin typeface="Gilroy" panose="020B0604020202020204" charset="0"/>
+              <a:ea typeface="Gilroy"/>
+              <a:cs typeface="Gilroy"/>
+              <a:sym typeface="Gilroy"/>
+            </a:endParaRPr>
+          </a:p>
+        </p:txBody>
+      </p:sp>
+      <p:sp>
+        <p:nvSpPr>
+          <p:cNvPr id="10" name="TextBox 5">
+            <a:extLst>
+              <a:ext uri="{FF2B5EF4-FFF2-40B4-BE49-F238E27FC236}">
+                <a16:creationId xmlns:a16="http://schemas.microsoft.com/office/drawing/2014/main" id="{46697F84-209C-49B1-914F-7BEE7C90CC4C}"/>
+              </a:ext>
+            </a:extLst>
+          </p:cNvPr>
+          <p:cNvSpPr txBox="1"/>
+          <p:nvPr/>
+        </p:nvSpPr>
+        <p:spPr>
+          <a:xfrm>
+            <a:off x="3727112" y="6804684"/>
+            <a:ext cx="2340581" cy="627736"/>
+          </a:xfrm>
+          <a:prstGeom prst="rect">
+            <a:avLst/>
+          </a:prstGeom>
+        </p:spPr>
+        <p:txBody>
+          <a:bodyPr wrap="square" lIns="0" tIns="0" rIns="0" bIns="0" rtlCol="0" anchor="t">
+            <a:spAutoFit/>
+          </a:bodyPr>
+          <a:lstStyle/>
+          <a:p>
+            <a:pPr>
+              <a:lnSpc>
+                <a:spcPts val="5559"/>
+              </a:lnSpc>
+            </a:pPr>
+            <a:r>
+              <a:rPr lang="en-US" sz="2800" dirty="0" err="1">
+                <a:latin typeface="Gilroy" panose="020B0604020202020204" charset="0"/>
+                <a:ea typeface="Gilroy"/>
+                <a:cs typeface="Gilroy"/>
+                <a:sym typeface="Gilroy"/>
+              </a:rPr>
+              <a:t>Inasistencias</a:t>
+            </a:r>
+            <a:endParaRPr lang="en-US" sz="2800" dirty="0">
+              <a:latin typeface="Gilroy" panose="020B0604020202020204" charset="0"/>
+              <a:ea typeface="Gilroy"/>
+              <a:cs typeface="Gilroy"/>
+              <a:sym typeface="Gilroy"/>
+            </a:endParaRPr>
+          </a:p>
+        </p:txBody>
+      </p:sp>
+      <p:sp>
+        <p:nvSpPr>
+          <p:cNvPr id="11" name="TextBox 5">
+            <a:extLst>
+              <a:ext uri="{FF2B5EF4-FFF2-40B4-BE49-F238E27FC236}">
+                <a16:creationId xmlns:a16="http://schemas.microsoft.com/office/drawing/2014/main" id="{780C7D75-8A2B-4191-A7A3-CF5E7B6F2B87}"/>
+              </a:ext>
+            </a:extLst>
+          </p:cNvPr>
+          <p:cNvSpPr txBox="1"/>
+          <p:nvPr/>
+        </p:nvSpPr>
+        <p:spPr>
+          <a:xfrm>
+            <a:off x="7934695" y="7622725"/>
+            <a:ext cx="4699523" cy="627736"/>
+          </a:xfrm>
+          <a:prstGeom prst="rect">
+            <a:avLst/>
+          </a:prstGeom>
+        </p:spPr>
+        <p:txBody>
+          <a:bodyPr wrap="square" lIns="0" tIns="0" rIns="0" bIns="0" rtlCol="0" anchor="t">
+            <a:spAutoFit/>
+          </a:bodyPr>
+          <a:lstStyle/>
+          <a:p>
+            <a:pPr>
+              <a:lnSpc>
+                <a:spcPts val="5559"/>
+              </a:lnSpc>
+            </a:pPr>
+            <a:r>
+              <a:rPr lang="en-US" sz="2800" dirty="0">
+                <a:latin typeface="Gilroy"/>
+                <a:ea typeface="Gilroy"/>
+                <a:cs typeface="Gilroy"/>
+                <a:sym typeface="Gilroy"/>
+              </a:rPr>
+              <a:t>47.60% de </a:t>
+            </a:r>
+            <a:r>
+              <a:rPr lang="en-US" sz="2800" dirty="0" err="1">
+                <a:latin typeface="Gilroy"/>
+                <a:ea typeface="Gilroy"/>
+                <a:cs typeface="Gilroy"/>
+                <a:sym typeface="Gilroy"/>
+              </a:rPr>
+              <a:t>cumplimiento</a:t>
+            </a:r>
+            <a:endParaRPr lang="en-US" sz="2800" dirty="0">
+              <a:latin typeface="Gilroy"/>
+              <a:ea typeface="Gilroy"/>
+              <a:cs typeface="Gilroy"/>
+              <a:sym typeface="Gilroy"/>
+            </a:endParaRPr>
+          </a:p>
+        </p:txBody>
+      </p:sp>
+      <p:sp>
+        <p:nvSpPr>
+          <p:cNvPr id="12" name="TextBox 3">
+            <a:extLst>
+              <a:ext uri="{FF2B5EF4-FFF2-40B4-BE49-F238E27FC236}">
+                <a16:creationId xmlns:a16="http://schemas.microsoft.com/office/drawing/2014/main" id="{0C08695E-35D2-4395-AF9D-9B144F4578E9}"/>
+              </a:ext>
+            </a:extLst>
+          </p:cNvPr>
+          <p:cNvSpPr txBox="1"/>
+          <p:nvPr/>
+        </p:nvSpPr>
+        <p:spPr>
+          <a:xfrm>
+            <a:off x="914400" y="3150905"/>
+            <a:ext cx="2155286" cy="1192634"/>
+          </a:xfrm>
+          <a:prstGeom prst="rect">
+            <a:avLst/>
+          </a:prstGeom>
+        </p:spPr>
+        <p:txBody>
+          <a:bodyPr wrap="square" lIns="0" tIns="0" rIns="0" bIns="0" rtlCol="0" anchor="t">
+            <a:spAutoFit/>
+          </a:bodyPr>
+          <a:lstStyle/>
+          <a:p>
+            <a:pPr>
+              <a:lnSpc>
+                <a:spcPts val="9264"/>
+              </a:lnSpc>
+              <a:spcBef>
+                <a:spcPct val="0"/>
+              </a:spcBef>
+            </a:pPr>
+            <a:r>
+              <a:rPr lang="en-US" sz="8000" b="1" dirty="0">
+                <a:solidFill>
+                  <a:srgbClr val="CFAB7E"/>
+                </a:solidFill>
+                <a:latin typeface="Gilroy Bold"/>
+                <a:ea typeface="Gilroy Bold"/>
+                <a:cs typeface="Gilroy Bold"/>
+                <a:sym typeface="Gilroy Bold"/>
+              </a:rPr>
+              <a:t>1029</a:t>
+            </a:r>
+          </a:p>
+        </p:txBody>
+      </p:sp>
+      <p:sp>
+        <p:nvSpPr>
+          <p:cNvPr id="20" name="TextBox 3">
+            <a:extLst>
+              <a:ext uri="{FF2B5EF4-FFF2-40B4-BE49-F238E27FC236}">
+                <a16:creationId xmlns:a16="http://schemas.microsoft.com/office/drawing/2014/main" id="{0E9B59A0-A71B-46C7-AE70-6528C926EA04}"/>
+              </a:ext>
+            </a:extLst>
+          </p:cNvPr>
+          <p:cNvSpPr txBox="1"/>
+          <p:nvPr/>
+        </p:nvSpPr>
+        <p:spPr>
+          <a:xfrm>
+            <a:off x="3727112" y="4808263"/>
+            <a:ext cx="1893793" cy="1192634"/>
+          </a:xfrm>
+          <a:prstGeom prst="rect">
+            <a:avLst/>
+          </a:prstGeom>
+        </p:spPr>
+        <p:txBody>
+          <a:bodyPr wrap="square" lIns="0" tIns="0" rIns="0" bIns="0" rtlCol="0" anchor="t">
+            <a:spAutoFit/>
+          </a:bodyPr>
+          <a:lstStyle/>
+          <a:p>
+            <a:pPr>
+              <a:lnSpc>
+                <a:spcPts val="9264"/>
+              </a:lnSpc>
+              <a:spcBef>
+                <a:spcPct val="0"/>
+              </a:spcBef>
+            </a:pPr>
+            <a:r>
+              <a:rPr lang="en-US" sz="8000" b="1" dirty="0">
+                <a:solidFill>
+                  <a:srgbClr val="0D312D"/>
+                </a:solidFill>
+                <a:latin typeface="Gilroy Bold"/>
+                <a:ea typeface="Gilroy Bold"/>
+                <a:cs typeface="Gilroy Bold"/>
+                <a:sym typeface="Gilroy Bold"/>
+              </a:rPr>
+              <a:t>517</a:t>
+            </a:r>
+          </a:p>
+        </p:txBody>
+      </p:sp>
+      <p:sp>
+        <p:nvSpPr>
+          <p:cNvPr id="21" name="TextBox 3">
+            <a:extLst>
+              <a:ext uri="{FF2B5EF4-FFF2-40B4-BE49-F238E27FC236}">
+                <a16:creationId xmlns:a16="http://schemas.microsoft.com/office/drawing/2014/main" id="{00C803A2-83EF-465E-8771-DE60231D0F81}"/>
+              </a:ext>
+            </a:extLst>
+          </p:cNvPr>
+          <p:cNvSpPr txBox="1"/>
+          <p:nvPr/>
+        </p:nvSpPr>
+        <p:spPr>
+          <a:xfrm>
+            <a:off x="1726384" y="6487597"/>
+            <a:ext cx="1893793" cy="1192634"/>
+          </a:xfrm>
+          <a:prstGeom prst="rect">
+            <a:avLst/>
+          </a:prstGeom>
+        </p:spPr>
+        <p:txBody>
+          <a:bodyPr wrap="square" lIns="0" tIns="0" rIns="0" bIns="0" rtlCol="0" anchor="t">
+            <a:spAutoFit/>
+          </a:bodyPr>
+          <a:lstStyle/>
+          <a:p>
+            <a:pPr>
+              <a:lnSpc>
+                <a:spcPts val="9264"/>
+              </a:lnSpc>
+              <a:spcBef>
+                <a:spcPct val="0"/>
+              </a:spcBef>
+            </a:pPr>
+            <a:r>
+              <a:rPr lang="en-US" sz="8000" b="1" dirty="0">
+                <a:solidFill>
+                  <a:srgbClr val="841E38"/>
+                </a:solidFill>
+                <a:latin typeface="Gilroy Bold"/>
+                <a:ea typeface="Gilroy Bold"/>
+                <a:cs typeface="Gilroy Bold"/>
+                <a:sym typeface="Gilroy Bold"/>
+              </a:rPr>
+              <a:t>568</a:t>
+            </a:r>
+          </a:p>
+        </p:txBody>
+      </p:sp>
+      <p:sp>
+        <p:nvSpPr>
+          <p:cNvPr id="24" name="Elipse 23">
+            <a:extLst>
+              <a:ext uri="{FF2B5EF4-FFF2-40B4-BE49-F238E27FC236}">
+                <a16:creationId xmlns:a16="http://schemas.microsoft.com/office/drawing/2014/main" id="{7D2D1E8A-3330-4290-A36A-897BDFA341CD}"/>
+              </a:ext>
+            </a:extLst>
+          </p:cNvPr>
+          <p:cNvSpPr/>
+          <p:nvPr/>
+        </p:nvSpPr>
+        <p:spPr>
+          <a:xfrm>
+            <a:off x="7524507" y="2910974"/>
+            <a:ext cx="4572043" cy="4274623"/>
+          </a:xfrm>
+          <a:prstGeom prst="ellipse">
+            <a:avLst/>
+          </a:prstGeom>
+          <a:solidFill>
+            <a:srgbClr val="0D312D"/>
+          </a:solidFill>
+        </p:spPr>
+        <p:style>
+          <a:lnRef idx="2">
+            <a:schemeClr val="accent1">
+              <a:shade val="50000"/>
+            </a:schemeClr>
+          </a:lnRef>
+          <a:fillRef idx="1">
+            <a:schemeClr val="accent1"/>
+          </a:fillRef>
+          <a:effectRef idx="0">
+            <a:schemeClr val="accent1"/>
+          </a:effectRef>
+          <a:fontRef idx="minor">
+            <a:schemeClr val="lt1"/>
+          </a:fontRef>
+        </p:style>
+        <p:txBody>
+          <a:bodyPr rtlCol="0" anchor="ctr"/>
+          <a:lstStyle/>
+          <a:p>
+            <a:pPr algn="ctr"/>
+            <a:endParaRPr lang="es-MX"/>
+          </a:p>
+        </p:txBody>
+      </p:sp>
+      <p:sp>
+        <p:nvSpPr>
+          <p:cNvPr id="25" name="TextBox 5">
+            <a:extLst>
+              <a:ext uri="{FF2B5EF4-FFF2-40B4-BE49-F238E27FC236}">
+                <a16:creationId xmlns:a16="http://schemas.microsoft.com/office/drawing/2014/main" id="{B858F9DE-310A-484F-8759-FADD5C0F8500}"/>
+              </a:ext>
+            </a:extLst>
+          </p:cNvPr>
+          <p:cNvSpPr txBox="1"/>
+          <p:nvPr/>
+        </p:nvSpPr>
+        <p:spPr>
+          <a:xfrm>
+            <a:off x="7088214" y="1811891"/>
+            <a:ext cx="5444627" cy="627736"/>
+          </a:xfrm>
+          <a:prstGeom prst="rect">
+            <a:avLst/>
+          </a:prstGeom>
+        </p:spPr>
+        <p:txBody>
+          <a:bodyPr wrap="square" lIns="0" tIns="0" rIns="0" bIns="0" rtlCol="0" anchor="t">
+            <a:spAutoFit/>
+          </a:bodyPr>
+          <a:lstStyle/>
+          <a:p>
+            <a:pPr>
+              <a:lnSpc>
+                <a:spcPts val="5559"/>
+              </a:lnSpc>
+            </a:pPr>
+            <a:r>
+              <a:rPr lang="en-US" sz="2800" dirty="0" err="1">
+                <a:latin typeface="Gilroy"/>
+                <a:ea typeface="Gilroy"/>
+                <a:cs typeface="Gilroy"/>
+                <a:sym typeface="Gilroy"/>
+              </a:rPr>
+              <a:t>Semana</a:t>
+            </a:r>
+            <a:r>
+              <a:rPr lang="en-US" sz="2800" dirty="0">
+                <a:latin typeface="Gilroy"/>
+                <a:ea typeface="Gilroy"/>
+                <a:cs typeface="Gilroy"/>
+                <a:sym typeface="Gilroy"/>
+              </a:rPr>
+              <a:t> 1 al 6 de </a:t>
+            </a:r>
+            <a:r>
+              <a:rPr lang="en-US" sz="2800" dirty="0" err="1">
+                <a:latin typeface="Gilroy"/>
+                <a:ea typeface="Gilroy"/>
+                <a:cs typeface="Gilroy"/>
+                <a:sym typeface="Gilroy"/>
+              </a:rPr>
+              <a:t>febrero</a:t>
+            </a:r>
+            <a:r>
+              <a:rPr lang="en-US" sz="2800" dirty="0">
+                <a:latin typeface="Gilroy"/>
+                <a:ea typeface="Gilroy"/>
+                <a:cs typeface="Gilroy"/>
+                <a:sym typeface="Gilroy"/>
+              </a:rPr>
+              <a:t> de 2026</a:t>
+            </a:r>
+          </a:p>
+        </p:txBody>
+      </p:sp>
+    </p:spTree>
+  </p:cSld>
+  <p:clrMapOvr>
+    <a:masterClrMapping/>
+  </p:clrMapOvr>
+</p:sld>
+</file>
+
+<file path=ppt/slides/slide4.xml><?xml version="1.0" encoding="utf-8"?>
 <p:sld xmlns:a="http://schemas.openxmlformats.org/drawingml/2006/main" xmlns:r="http://schemas.openxmlformats.org/officeDocument/2006/relationships" xmlns:p="http://schemas.openxmlformats.org/presentationml/2006/main">
   <p:cSld>
     <p:spTree>
@@ -3564,14 +4851,20 @@
       </p:grpSp>
       <p:sp>
         <p:nvSpPr>
-          <p:cNvPr id="6" name="TextBox 6"/>
+          <p:cNvPr id="8" name="TextBox 7">
+            <a:extLst>
+              <a:ext uri="{FF2B5EF4-FFF2-40B4-BE49-F238E27FC236}">
+                <a16:creationId xmlns:a16="http://schemas.microsoft.com/office/drawing/2014/main" id="{AC59E47A-7670-4641-B491-F82E5B07D4BE}"/>
+              </a:ext>
+            </a:extLst>
+          </p:cNvPr>
           <p:cNvSpPr txBox="1"/>
           <p:nvPr/>
         </p:nvSpPr>
         <p:spPr>
           <a:xfrm>
-            <a:off x="1230407" y="1635710"/>
-            <a:ext cx="2659996" cy="312073"/>
+            <a:off x="1076324" y="3061508"/>
+            <a:ext cx="10302195" cy="1309333"/>
           </a:xfrm>
           <a:prstGeom prst="rect">
             <a:avLst/>
@@ -3583,39 +4876,690 @@
           </a:bodyPr>
           <a:lstStyle/>
           <a:p>
-            <a:pPr algn="ctr">
+            <a:pPr algn="just">
               <a:lnSpc>
                 <a:spcPts val="2593"/>
               </a:lnSpc>
-              <a:spcBef>
-                <a:spcPct val="0"/>
-              </a:spcBef>
             </a:pPr>
             <a:r>
-              <a:rPr lang="en-US" sz="1852" b="1">
+              <a:rPr lang="en-US" sz="1852" dirty="0">
                 <a:solidFill>
                   <a:srgbClr val="000000"/>
                 </a:solidFill>
-                <a:latin typeface="Gilroy Bold"/>
-                <a:ea typeface="Gilroy Bold"/>
-                <a:cs typeface="Gilroy Bold"/>
-                <a:sym typeface="Gilroy Bold"/>
-              </a:rPr>
-              <a:t>Base para presentación </a:t>
-            </a:r>
-          </a:p>
-        </p:txBody>
-      </p:sp>
-      <p:sp>
-        <p:nvSpPr>
-          <p:cNvPr id="7" name="TextBox 7"/>
+                <a:latin typeface="Gilroy"/>
+                <a:ea typeface="Gilroy"/>
+                <a:cs typeface="Gilroy"/>
+                <a:sym typeface="Gilroy"/>
+              </a:rPr>
+              <a:t>Lorem ipsum dolor sit </a:t>
+            </a:r>
+            <a:r>
+              <a:rPr lang="en-US" sz="1852" dirty="0" err="1">
+                <a:solidFill>
+                  <a:srgbClr val="000000"/>
+                </a:solidFill>
+                <a:latin typeface="Gilroy"/>
+                <a:ea typeface="Gilroy"/>
+                <a:cs typeface="Gilroy"/>
+                <a:sym typeface="Gilroy"/>
+              </a:rPr>
+              <a:t>amet</a:t>
+            </a:r>
+            <a:r>
+              <a:rPr lang="en-US" sz="1852" dirty="0">
+                <a:solidFill>
+                  <a:srgbClr val="000000"/>
+                </a:solidFill>
+                <a:latin typeface="Gilroy"/>
+                <a:ea typeface="Gilroy"/>
+                <a:cs typeface="Gilroy"/>
+                <a:sym typeface="Gilroy"/>
+              </a:rPr>
+              <a:t>, </a:t>
+            </a:r>
+            <a:r>
+              <a:rPr lang="en-US" sz="1852" dirty="0" err="1">
+                <a:solidFill>
+                  <a:srgbClr val="000000"/>
+                </a:solidFill>
+                <a:latin typeface="Gilroy"/>
+                <a:ea typeface="Gilroy"/>
+                <a:cs typeface="Gilroy"/>
+                <a:sym typeface="Gilroy"/>
+              </a:rPr>
+              <a:t>consectetur</a:t>
+            </a:r>
+            <a:r>
+              <a:rPr lang="en-US" sz="1852" dirty="0">
+                <a:solidFill>
+                  <a:srgbClr val="000000"/>
+                </a:solidFill>
+                <a:latin typeface="Gilroy"/>
+                <a:ea typeface="Gilroy"/>
+                <a:cs typeface="Gilroy"/>
+                <a:sym typeface="Gilroy"/>
+              </a:rPr>
+              <a:t> </a:t>
+            </a:r>
+            <a:r>
+              <a:rPr lang="en-US" sz="1852" dirty="0" err="1">
+                <a:solidFill>
+                  <a:srgbClr val="000000"/>
+                </a:solidFill>
+                <a:latin typeface="Gilroy"/>
+                <a:ea typeface="Gilroy"/>
+                <a:cs typeface="Gilroy"/>
+                <a:sym typeface="Gilroy"/>
+              </a:rPr>
+              <a:t>adipiscing</a:t>
+            </a:r>
+            <a:r>
+              <a:rPr lang="en-US" sz="1852" dirty="0">
+                <a:solidFill>
+                  <a:srgbClr val="000000"/>
+                </a:solidFill>
+                <a:latin typeface="Gilroy"/>
+                <a:ea typeface="Gilroy"/>
+                <a:cs typeface="Gilroy"/>
+                <a:sym typeface="Gilroy"/>
+              </a:rPr>
+              <a:t> </a:t>
+            </a:r>
+            <a:r>
+              <a:rPr lang="en-US" sz="1852" dirty="0" err="1">
+                <a:solidFill>
+                  <a:srgbClr val="000000"/>
+                </a:solidFill>
+                <a:latin typeface="Gilroy"/>
+                <a:ea typeface="Gilroy"/>
+                <a:cs typeface="Gilroy"/>
+                <a:sym typeface="Gilroy"/>
+              </a:rPr>
+              <a:t>elit</a:t>
+            </a:r>
+            <a:r>
+              <a:rPr lang="en-US" sz="1852" dirty="0">
+                <a:solidFill>
+                  <a:srgbClr val="000000"/>
+                </a:solidFill>
+                <a:latin typeface="Gilroy"/>
+                <a:ea typeface="Gilroy"/>
+                <a:cs typeface="Gilroy"/>
+                <a:sym typeface="Gilroy"/>
+              </a:rPr>
+              <a:t>, sed do </a:t>
+            </a:r>
+            <a:r>
+              <a:rPr lang="en-US" sz="1852" dirty="0" err="1">
+                <a:solidFill>
+                  <a:srgbClr val="000000"/>
+                </a:solidFill>
+                <a:latin typeface="Gilroy"/>
+                <a:ea typeface="Gilroy"/>
+                <a:cs typeface="Gilroy"/>
+                <a:sym typeface="Gilroy"/>
+              </a:rPr>
+              <a:t>eiusmod</a:t>
+            </a:r>
+            <a:r>
+              <a:rPr lang="en-US" sz="1852" dirty="0">
+                <a:solidFill>
+                  <a:srgbClr val="000000"/>
+                </a:solidFill>
+                <a:latin typeface="Gilroy"/>
+                <a:ea typeface="Gilroy"/>
+                <a:cs typeface="Gilroy"/>
+                <a:sym typeface="Gilroy"/>
+              </a:rPr>
+              <a:t> </a:t>
+            </a:r>
+            <a:r>
+              <a:rPr lang="en-US" sz="1852" dirty="0" err="1">
+                <a:solidFill>
+                  <a:srgbClr val="000000"/>
+                </a:solidFill>
+                <a:latin typeface="Gilroy"/>
+                <a:ea typeface="Gilroy"/>
+                <a:cs typeface="Gilroy"/>
+                <a:sym typeface="Gilroy"/>
+              </a:rPr>
+              <a:t>tempor</a:t>
+            </a:r>
+            <a:r>
+              <a:rPr lang="en-US" sz="1852" dirty="0">
+                <a:solidFill>
+                  <a:srgbClr val="000000"/>
+                </a:solidFill>
+                <a:latin typeface="Gilroy"/>
+                <a:ea typeface="Gilroy"/>
+                <a:cs typeface="Gilroy"/>
+                <a:sym typeface="Gilroy"/>
+              </a:rPr>
+              <a:t> </a:t>
+            </a:r>
+            <a:r>
+              <a:rPr lang="en-US" sz="1852" dirty="0" err="1">
+                <a:solidFill>
+                  <a:srgbClr val="000000"/>
+                </a:solidFill>
+                <a:latin typeface="Gilroy"/>
+                <a:ea typeface="Gilroy"/>
+                <a:cs typeface="Gilroy"/>
+                <a:sym typeface="Gilroy"/>
+              </a:rPr>
+              <a:t>incididunt</a:t>
+            </a:r>
+            <a:r>
+              <a:rPr lang="en-US" sz="1852" dirty="0">
+                <a:solidFill>
+                  <a:srgbClr val="000000"/>
+                </a:solidFill>
+                <a:latin typeface="Gilroy"/>
+                <a:ea typeface="Gilroy"/>
+                <a:cs typeface="Gilroy"/>
+                <a:sym typeface="Gilroy"/>
+              </a:rPr>
+              <a:t> </a:t>
+            </a:r>
+            <a:r>
+              <a:rPr lang="en-US" sz="1852" dirty="0" err="1">
+                <a:solidFill>
+                  <a:srgbClr val="000000"/>
+                </a:solidFill>
+                <a:latin typeface="Gilroy"/>
+                <a:ea typeface="Gilroy"/>
+                <a:cs typeface="Gilroy"/>
+                <a:sym typeface="Gilroy"/>
+              </a:rPr>
+              <a:t>ut</a:t>
+            </a:r>
+            <a:r>
+              <a:rPr lang="en-US" sz="1852" dirty="0">
+                <a:solidFill>
+                  <a:srgbClr val="000000"/>
+                </a:solidFill>
+                <a:latin typeface="Gilroy"/>
+                <a:ea typeface="Gilroy"/>
+                <a:cs typeface="Gilroy"/>
+                <a:sym typeface="Gilroy"/>
+              </a:rPr>
+              <a:t> labore et dolore magna </a:t>
+            </a:r>
+            <a:r>
+              <a:rPr lang="en-US" sz="1852" dirty="0" err="1">
+                <a:solidFill>
+                  <a:srgbClr val="000000"/>
+                </a:solidFill>
+                <a:latin typeface="Gilroy"/>
+                <a:ea typeface="Gilroy"/>
+                <a:cs typeface="Gilroy"/>
+                <a:sym typeface="Gilroy"/>
+              </a:rPr>
+              <a:t>aliqua</a:t>
+            </a:r>
+            <a:r>
+              <a:rPr lang="en-US" sz="1852" dirty="0">
+                <a:solidFill>
+                  <a:srgbClr val="000000"/>
+                </a:solidFill>
+                <a:latin typeface="Gilroy"/>
+                <a:ea typeface="Gilroy"/>
+                <a:cs typeface="Gilroy"/>
+                <a:sym typeface="Gilroy"/>
+              </a:rPr>
+              <a:t>. Ut </a:t>
+            </a:r>
+            <a:r>
+              <a:rPr lang="en-US" sz="1852" dirty="0" err="1">
+                <a:solidFill>
+                  <a:srgbClr val="000000"/>
+                </a:solidFill>
+                <a:latin typeface="Gilroy"/>
+                <a:ea typeface="Gilroy"/>
+                <a:cs typeface="Gilroy"/>
+                <a:sym typeface="Gilroy"/>
+              </a:rPr>
+              <a:t>enim</a:t>
+            </a:r>
+            <a:r>
+              <a:rPr lang="en-US" sz="1852" dirty="0">
+                <a:solidFill>
+                  <a:srgbClr val="000000"/>
+                </a:solidFill>
+                <a:latin typeface="Gilroy"/>
+                <a:ea typeface="Gilroy"/>
+                <a:cs typeface="Gilroy"/>
+                <a:sym typeface="Gilroy"/>
+              </a:rPr>
+              <a:t> ad minim </a:t>
+            </a:r>
+            <a:r>
+              <a:rPr lang="en-US" sz="1852" dirty="0" err="1">
+                <a:solidFill>
+                  <a:srgbClr val="000000"/>
+                </a:solidFill>
+                <a:latin typeface="Gilroy"/>
+                <a:ea typeface="Gilroy"/>
+                <a:cs typeface="Gilroy"/>
+                <a:sym typeface="Gilroy"/>
+              </a:rPr>
+              <a:t>veniam</a:t>
+            </a:r>
+            <a:r>
+              <a:rPr lang="en-US" sz="1852" dirty="0">
+                <a:solidFill>
+                  <a:srgbClr val="000000"/>
+                </a:solidFill>
+                <a:latin typeface="Gilroy"/>
+                <a:ea typeface="Gilroy"/>
+                <a:cs typeface="Gilroy"/>
+                <a:sym typeface="Gilroy"/>
+              </a:rPr>
+              <a:t>, </a:t>
+            </a:r>
+            <a:r>
+              <a:rPr lang="en-US" sz="1852" dirty="0" err="1">
+                <a:solidFill>
+                  <a:srgbClr val="000000"/>
+                </a:solidFill>
+                <a:latin typeface="Gilroy"/>
+                <a:ea typeface="Gilroy"/>
+                <a:cs typeface="Gilroy"/>
+                <a:sym typeface="Gilroy"/>
+              </a:rPr>
+              <a:t>quis</a:t>
+            </a:r>
+            <a:r>
+              <a:rPr lang="en-US" sz="1852" dirty="0">
+                <a:solidFill>
+                  <a:srgbClr val="000000"/>
+                </a:solidFill>
+                <a:latin typeface="Gilroy"/>
+                <a:ea typeface="Gilroy"/>
+                <a:cs typeface="Gilroy"/>
+                <a:sym typeface="Gilroy"/>
+              </a:rPr>
+              <a:t> </a:t>
+            </a:r>
+            <a:r>
+              <a:rPr lang="en-US" sz="1852" dirty="0" err="1">
+                <a:solidFill>
+                  <a:srgbClr val="000000"/>
+                </a:solidFill>
+                <a:latin typeface="Gilroy"/>
+                <a:ea typeface="Gilroy"/>
+                <a:cs typeface="Gilroy"/>
+                <a:sym typeface="Gilroy"/>
+              </a:rPr>
+              <a:t>nostrud</a:t>
+            </a:r>
+            <a:r>
+              <a:rPr lang="en-US" sz="1852" dirty="0">
+                <a:solidFill>
+                  <a:srgbClr val="000000"/>
+                </a:solidFill>
+                <a:latin typeface="Gilroy"/>
+                <a:ea typeface="Gilroy"/>
+                <a:cs typeface="Gilroy"/>
+                <a:sym typeface="Gilroy"/>
+              </a:rPr>
+              <a:t> exercitation </a:t>
+            </a:r>
+            <a:r>
+              <a:rPr lang="en-US" sz="1852" dirty="0" err="1">
+                <a:solidFill>
+                  <a:srgbClr val="000000"/>
+                </a:solidFill>
+                <a:latin typeface="Gilroy"/>
+                <a:ea typeface="Gilroy"/>
+                <a:cs typeface="Gilroy"/>
+                <a:sym typeface="Gilroy"/>
+              </a:rPr>
+              <a:t>ullamco</a:t>
+            </a:r>
+            <a:r>
+              <a:rPr lang="en-US" sz="1852" dirty="0">
+                <a:solidFill>
+                  <a:srgbClr val="000000"/>
+                </a:solidFill>
+                <a:latin typeface="Gilroy"/>
+                <a:ea typeface="Gilroy"/>
+                <a:cs typeface="Gilroy"/>
+                <a:sym typeface="Gilroy"/>
+              </a:rPr>
+              <a:t> </a:t>
+            </a:r>
+            <a:r>
+              <a:rPr lang="en-US" sz="1852" dirty="0" err="1">
+                <a:solidFill>
+                  <a:srgbClr val="000000"/>
+                </a:solidFill>
+                <a:latin typeface="Gilroy"/>
+                <a:ea typeface="Gilroy"/>
+                <a:cs typeface="Gilroy"/>
+                <a:sym typeface="Gilroy"/>
+              </a:rPr>
+              <a:t>laboris</a:t>
+            </a:r>
+            <a:r>
+              <a:rPr lang="en-US" sz="1852" dirty="0">
+                <a:solidFill>
+                  <a:srgbClr val="000000"/>
+                </a:solidFill>
+                <a:latin typeface="Gilroy"/>
+                <a:ea typeface="Gilroy"/>
+                <a:cs typeface="Gilroy"/>
+                <a:sym typeface="Gilroy"/>
+              </a:rPr>
+              <a:t> nisi </a:t>
+            </a:r>
+            <a:r>
+              <a:rPr lang="en-US" sz="1852" dirty="0" err="1">
+                <a:solidFill>
+                  <a:srgbClr val="000000"/>
+                </a:solidFill>
+                <a:latin typeface="Gilroy"/>
+                <a:ea typeface="Gilroy"/>
+                <a:cs typeface="Gilroy"/>
+                <a:sym typeface="Gilroy"/>
+              </a:rPr>
+              <a:t>ut</a:t>
+            </a:r>
+            <a:r>
+              <a:rPr lang="en-US" sz="1852" dirty="0">
+                <a:solidFill>
+                  <a:srgbClr val="000000"/>
+                </a:solidFill>
+                <a:latin typeface="Gilroy"/>
+                <a:ea typeface="Gilroy"/>
+                <a:cs typeface="Gilroy"/>
+                <a:sym typeface="Gilroy"/>
+              </a:rPr>
+              <a:t> </a:t>
+            </a:r>
+            <a:r>
+              <a:rPr lang="en-US" sz="1852" dirty="0" err="1">
+                <a:solidFill>
+                  <a:srgbClr val="000000"/>
+                </a:solidFill>
+                <a:latin typeface="Gilroy"/>
+                <a:ea typeface="Gilroy"/>
+                <a:cs typeface="Gilroy"/>
+                <a:sym typeface="Gilroy"/>
+              </a:rPr>
+              <a:t>aliquip</a:t>
+            </a:r>
+            <a:r>
+              <a:rPr lang="en-US" sz="1852" dirty="0">
+                <a:solidFill>
+                  <a:srgbClr val="000000"/>
+                </a:solidFill>
+                <a:latin typeface="Gilroy"/>
+                <a:ea typeface="Gilroy"/>
+                <a:cs typeface="Gilroy"/>
+                <a:sym typeface="Gilroy"/>
+              </a:rPr>
+              <a:t> ex </a:t>
+            </a:r>
+            <a:r>
+              <a:rPr lang="en-US" sz="1852" dirty="0" err="1">
+                <a:solidFill>
+                  <a:srgbClr val="000000"/>
+                </a:solidFill>
+                <a:latin typeface="Gilroy"/>
+                <a:ea typeface="Gilroy"/>
+                <a:cs typeface="Gilroy"/>
+                <a:sym typeface="Gilroy"/>
+              </a:rPr>
+              <a:t>ea</a:t>
+            </a:r>
+            <a:r>
+              <a:rPr lang="en-US" sz="1852" dirty="0">
+                <a:solidFill>
+                  <a:srgbClr val="000000"/>
+                </a:solidFill>
+                <a:latin typeface="Gilroy"/>
+                <a:ea typeface="Gilroy"/>
+                <a:cs typeface="Gilroy"/>
+                <a:sym typeface="Gilroy"/>
+              </a:rPr>
+              <a:t> </a:t>
+            </a:r>
+            <a:r>
+              <a:rPr lang="en-US" sz="1852" dirty="0" err="1">
+                <a:solidFill>
+                  <a:srgbClr val="000000"/>
+                </a:solidFill>
+                <a:latin typeface="Gilroy"/>
+                <a:ea typeface="Gilroy"/>
+                <a:cs typeface="Gilroy"/>
+                <a:sym typeface="Gilroy"/>
+              </a:rPr>
+              <a:t>commodo</a:t>
+            </a:r>
+            <a:r>
+              <a:rPr lang="en-US" sz="1852" dirty="0">
+                <a:solidFill>
+                  <a:srgbClr val="000000"/>
+                </a:solidFill>
+                <a:latin typeface="Gilroy"/>
+                <a:ea typeface="Gilroy"/>
+                <a:cs typeface="Gilroy"/>
+                <a:sym typeface="Gilroy"/>
+              </a:rPr>
+              <a:t> </a:t>
+            </a:r>
+            <a:r>
+              <a:rPr lang="en-US" sz="1852" dirty="0" err="1">
+                <a:solidFill>
+                  <a:srgbClr val="000000"/>
+                </a:solidFill>
+                <a:latin typeface="Gilroy"/>
+                <a:ea typeface="Gilroy"/>
+                <a:cs typeface="Gilroy"/>
+                <a:sym typeface="Gilroy"/>
+              </a:rPr>
+              <a:t>consequat</a:t>
+            </a:r>
+            <a:r>
+              <a:rPr lang="en-US" sz="1852" dirty="0">
+                <a:solidFill>
+                  <a:srgbClr val="000000"/>
+                </a:solidFill>
+                <a:latin typeface="Gilroy"/>
+                <a:ea typeface="Gilroy"/>
+                <a:cs typeface="Gilroy"/>
+                <a:sym typeface="Gilroy"/>
+              </a:rPr>
+              <a:t>. Duis </a:t>
+            </a:r>
+            <a:r>
+              <a:rPr lang="en-US" sz="1852" dirty="0" err="1">
+                <a:solidFill>
+                  <a:srgbClr val="000000"/>
+                </a:solidFill>
+                <a:latin typeface="Gilroy"/>
+                <a:ea typeface="Gilroy"/>
+                <a:cs typeface="Gilroy"/>
+                <a:sym typeface="Gilroy"/>
+              </a:rPr>
+              <a:t>aute</a:t>
+            </a:r>
+            <a:r>
+              <a:rPr lang="en-US" sz="1852" dirty="0">
+                <a:solidFill>
+                  <a:srgbClr val="000000"/>
+                </a:solidFill>
+                <a:latin typeface="Gilroy"/>
+                <a:ea typeface="Gilroy"/>
+                <a:cs typeface="Gilroy"/>
+                <a:sym typeface="Gilroy"/>
+              </a:rPr>
+              <a:t> </a:t>
+            </a:r>
+            <a:r>
+              <a:rPr lang="en-US" sz="1852" dirty="0" err="1">
+                <a:solidFill>
+                  <a:srgbClr val="000000"/>
+                </a:solidFill>
+                <a:latin typeface="Gilroy"/>
+                <a:ea typeface="Gilroy"/>
+                <a:cs typeface="Gilroy"/>
+                <a:sym typeface="Gilroy"/>
+              </a:rPr>
+              <a:t>irure</a:t>
+            </a:r>
+            <a:r>
+              <a:rPr lang="en-US" sz="1852" dirty="0">
+                <a:solidFill>
+                  <a:srgbClr val="000000"/>
+                </a:solidFill>
+                <a:latin typeface="Gilroy"/>
+                <a:ea typeface="Gilroy"/>
+                <a:cs typeface="Gilroy"/>
+                <a:sym typeface="Gilroy"/>
+              </a:rPr>
+              <a:t> dolor in </a:t>
+            </a:r>
+            <a:r>
+              <a:rPr lang="en-US" sz="1852" dirty="0" err="1">
+                <a:solidFill>
+                  <a:srgbClr val="000000"/>
+                </a:solidFill>
+                <a:latin typeface="Gilroy"/>
+                <a:ea typeface="Gilroy"/>
+                <a:cs typeface="Gilroy"/>
+                <a:sym typeface="Gilroy"/>
+              </a:rPr>
+              <a:t>reprehenderit</a:t>
+            </a:r>
+            <a:r>
+              <a:rPr lang="en-US" sz="1852" dirty="0">
+                <a:solidFill>
+                  <a:srgbClr val="000000"/>
+                </a:solidFill>
+                <a:latin typeface="Gilroy"/>
+                <a:ea typeface="Gilroy"/>
+                <a:cs typeface="Gilroy"/>
+                <a:sym typeface="Gilroy"/>
+              </a:rPr>
+              <a:t> in </a:t>
+            </a:r>
+            <a:r>
+              <a:rPr lang="en-US" sz="1852" dirty="0" err="1">
+                <a:solidFill>
+                  <a:srgbClr val="000000"/>
+                </a:solidFill>
+                <a:latin typeface="Gilroy"/>
+                <a:ea typeface="Gilroy"/>
+                <a:cs typeface="Gilroy"/>
+                <a:sym typeface="Gilroy"/>
+              </a:rPr>
+              <a:t>voluptate</a:t>
+            </a:r>
+            <a:r>
+              <a:rPr lang="en-US" sz="1852" dirty="0">
+                <a:solidFill>
+                  <a:srgbClr val="000000"/>
+                </a:solidFill>
+                <a:latin typeface="Gilroy"/>
+                <a:ea typeface="Gilroy"/>
+                <a:cs typeface="Gilroy"/>
+                <a:sym typeface="Gilroy"/>
+              </a:rPr>
+              <a:t> </a:t>
+            </a:r>
+            <a:r>
+              <a:rPr lang="en-US" sz="1852" dirty="0" err="1">
+                <a:solidFill>
+                  <a:srgbClr val="000000"/>
+                </a:solidFill>
+                <a:latin typeface="Gilroy"/>
+                <a:ea typeface="Gilroy"/>
+                <a:cs typeface="Gilroy"/>
+                <a:sym typeface="Gilroy"/>
+              </a:rPr>
+              <a:t>velit</a:t>
+            </a:r>
+            <a:r>
+              <a:rPr lang="en-US" sz="1852" dirty="0">
+                <a:solidFill>
+                  <a:srgbClr val="000000"/>
+                </a:solidFill>
+                <a:latin typeface="Gilroy"/>
+                <a:ea typeface="Gilroy"/>
+                <a:cs typeface="Gilroy"/>
+                <a:sym typeface="Gilroy"/>
+              </a:rPr>
+              <a:t> </a:t>
+            </a:r>
+            <a:r>
+              <a:rPr lang="en-US" sz="1852" dirty="0" err="1">
+                <a:solidFill>
+                  <a:srgbClr val="000000"/>
+                </a:solidFill>
+                <a:latin typeface="Gilroy"/>
+                <a:ea typeface="Gilroy"/>
+                <a:cs typeface="Gilroy"/>
+                <a:sym typeface="Gilroy"/>
+              </a:rPr>
+              <a:t>esse</a:t>
+            </a:r>
+            <a:r>
+              <a:rPr lang="en-US" sz="1852" dirty="0">
+                <a:solidFill>
+                  <a:srgbClr val="000000"/>
+                </a:solidFill>
+                <a:latin typeface="Gilroy"/>
+                <a:ea typeface="Gilroy"/>
+                <a:cs typeface="Gilroy"/>
+                <a:sym typeface="Gilroy"/>
+              </a:rPr>
+              <a:t> </a:t>
+            </a:r>
+            <a:r>
+              <a:rPr lang="en-US" sz="1852" dirty="0" err="1">
+                <a:solidFill>
+                  <a:srgbClr val="000000"/>
+                </a:solidFill>
+                <a:latin typeface="Gilroy"/>
+                <a:ea typeface="Gilroy"/>
+                <a:cs typeface="Gilroy"/>
+                <a:sym typeface="Gilroy"/>
+              </a:rPr>
+              <a:t>cillum</a:t>
+            </a:r>
+            <a:r>
+              <a:rPr lang="en-US" sz="1852" dirty="0">
+                <a:solidFill>
+                  <a:srgbClr val="000000"/>
+                </a:solidFill>
+                <a:latin typeface="Gilroy"/>
+                <a:ea typeface="Gilroy"/>
+                <a:cs typeface="Gilroy"/>
+                <a:sym typeface="Gilroy"/>
+              </a:rPr>
+              <a:t>.</a:t>
+            </a:r>
+          </a:p>
+        </p:txBody>
+      </p:sp>
+      <p:sp>
+        <p:nvSpPr>
+          <p:cNvPr id="9" name="TextBox 5">
+            <a:extLst>
+              <a:ext uri="{FF2B5EF4-FFF2-40B4-BE49-F238E27FC236}">
+                <a16:creationId xmlns:a16="http://schemas.microsoft.com/office/drawing/2014/main" id="{6028366B-0CF7-476F-9611-54EEE130F622}"/>
+              </a:ext>
+            </a:extLst>
+          </p:cNvPr>
           <p:cNvSpPr txBox="1"/>
           <p:nvPr/>
         </p:nvSpPr>
         <p:spPr>
           <a:xfrm>
-            <a:off x="1230406" y="2182721"/>
-            <a:ext cx="5627595" cy="6977551"/>
+            <a:off x="1085001" y="1866900"/>
+            <a:ext cx="5142421" cy="665054"/>
           </a:xfrm>
           <a:prstGeom prst="rect">
             <a:avLst/>
@@ -3627,92 +5571,22 @@
           </a:bodyPr>
           <a:lstStyle/>
           <a:p>
-            <a:pPr algn="just">
+            <a:pPr>
               <a:lnSpc>
-                <a:spcPts val="2593"/>
+                <a:spcPts val="5559"/>
               </a:lnSpc>
             </a:pPr>
             <a:r>
-              <a:rPr lang="en-US" sz="1852">
-                <a:solidFill>
-                  <a:srgbClr val="000000"/>
-                </a:solidFill>
-                <a:latin typeface="Gilroy"/>
-                <a:ea typeface="Gilroy"/>
-                <a:cs typeface="Gilroy"/>
-                <a:sym typeface="Gilroy"/>
-              </a:rPr>
-              <a:t>Lorem ipsum dolor sit amet, consectetur adipiscing elit, sed do eiusmod tempor incididunt ut labore et dolore magna aliqua. Ut enim ad minim veniam, quis nostrud exercitation ullamco laboris nisi ut aliquip ex ea commodo consequat. Duis aute irure dolor in reprehenderit in voluptate velit esse cillum dolore eu fugiat nulla pariatur. Excepteur sint occaecat cupidatat non proident, sunt in culpa qui officia deserunt mollit anim id est laborum.</a:t>
-            </a:r>
-          </a:p>
-          <a:p>
-            <a:pPr algn="just">
-              <a:lnSpc>
-                <a:spcPts val="2593"/>
-              </a:lnSpc>
-            </a:pPr>
-            <a:endParaRPr lang="en-US" sz="1852">
-              <a:solidFill>
-                <a:srgbClr val="000000"/>
-              </a:solidFill>
-              <a:latin typeface="Gilroy"/>
-              <a:ea typeface="Gilroy"/>
-              <a:cs typeface="Gilroy"/>
-              <a:sym typeface="Gilroy"/>
-            </a:endParaRPr>
-          </a:p>
-          <a:p>
-            <a:pPr algn="just">
-              <a:lnSpc>
-                <a:spcPts val="2593"/>
-              </a:lnSpc>
-            </a:pPr>
-            <a:r>
-              <a:rPr lang="en-US" sz="1852">
-                <a:solidFill>
-                  <a:srgbClr val="000000"/>
-                </a:solidFill>
-                <a:latin typeface="Gilroy"/>
-                <a:ea typeface="Gilroy"/>
-                <a:cs typeface="Gilroy"/>
-                <a:sym typeface="Gilroy"/>
-              </a:rPr>
-              <a:t>Lorem ipsum dolor sit amet, consectetur adipiscing elit, sed do eiusmod tempor incididunt ut labore et dolore magna aliqua. Ut enim ad minim veniam, quis nostrud exercitation ullamco laboris nisi ut aliquip ex ea commodo consequat. Duis aute irure dolor in reprehenderit in voluptate velit esse cillum dolore eu fugiat nulla pariatur. Excepteur sint occaecat cupidatat non proident, sunt in culpa qui officia deserunt mollit anim id est laborum.</a:t>
-            </a:r>
-          </a:p>
-          <a:p>
-            <a:pPr algn="just">
-              <a:lnSpc>
-                <a:spcPts val="2593"/>
-              </a:lnSpc>
-            </a:pPr>
-            <a:endParaRPr lang="en-US" sz="1852">
-              <a:solidFill>
-                <a:srgbClr val="000000"/>
-              </a:solidFill>
-              <a:latin typeface="Gilroy"/>
-              <a:ea typeface="Gilroy"/>
-              <a:cs typeface="Gilroy"/>
-              <a:sym typeface="Gilroy"/>
-            </a:endParaRPr>
-          </a:p>
-          <a:p>
-            <a:pPr algn="just">
-              <a:lnSpc>
-                <a:spcPts val="2593"/>
-              </a:lnSpc>
-            </a:pPr>
-            <a:r>
-              <a:rPr lang="en-US" sz="1852">
-                <a:solidFill>
-                  <a:srgbClr val="000000"/>
-                </a:solidFill>
-                <a:latin typeface="Gilroy"/>
-                <a:ea typeface="Gilroy"/>
-                <a:cs typeface="Gilroy"/>
-                <a:sym typeface="Gilroy"/>
-              </a:rPr>
-              <a:t>Para agregar la foto solo arrastra al marco -&gt;</a:t>
+              <a:rPr lang="en-US" sz="3971" dirty="0">
+                <a:solidFill>
+                  <a:srgbClr val="7D2B39"/>
+                </a:solidFill>
+                <a:latin typeface="Gilroy"/>
+                <a:ea typeface="Gilroy"/>
+                <a:cs typeface="Gilroy"/>
+                <a:sym typeface="Gilroy"/>
+              </a:rPr>
+              <a:t>Lorem ipsum</a:t>
             </a:r>
           </a:p>
         </p:txBody>
@@ -3725,270 +5599,7 @@
 </p:sld>
 </file>
 
-<file path=ppt/slides/slide3.xml><?xml version="1.0" encoding="utf-8"?>
-<p:sld xmlns:a="http://schemas.openxmlformats.org/drawingml/2006/main" xmlns:r="http://schemas.openxmlformats.org/officeDocument/2006/relationships" xmlns:p="http://schemas.openxmlformats.org/presentationml/2006/main">
-  <p:cSld>
-    <p:spTree>
-      <p:nvGrpSpPr>
-        <p:cNvPr id="1" name=""/>
-        <p:cNvGrpSpPr/>
-        <p:nvPr/>
-      </p:nvGrpSpPr>
-      <p:grpSpPr>
-        <a:xfrm>
-          <a:off x="0" y="0"/>
-          <a:ext cx="0" cy="0"/>
-          <a:chOff x="0" y="0"/>
-          <a:chExt cx="0" cy="0"/>
-        </a:xfrm>
-      </p:grpSpPr>
-      <p:grpSp>
-        <p:nvGrpSpPr>
-          <p:cNvPr id="2" name="Group 2"/>
-          <p:cNvGrpSpPr/>
-          <p:nvPr/>
-        </p:nvGrpSpPr>
-        <p:grpSpPr>
-          <a:xfrm>
-            <a:off x="0" y="2"/>
-            <a:ext cx="13715999" cy="10283975"/>
-            <a:chOff x="0" y="0"/>
-            <a:chExt cx="17750118" cy="13711966"/>
-          </a:xfrm>
-        </p:grpSpPr>
-        <p:sp>
-          <p:nvSpPr>
-            <p:cNvPr id="3" name="Freeform 3"/>
-            <p:cNvSpPr/>
-            <p:nvPr/>
-          </p:nvSpPr>
-          <p:spPr>
-            <a:xfrm>
-              <a:off x="0" y="0"/>
-              <a:ext cx="17750118" cy="13711966"/>
-            </a:xfrm>
-            <a:custGeom>
-              <a:avLst/>
-              <a:gdLst/>
-              <a:ahLst/>
-              <a:cxnLst/>
-              <a:rect l="l" t="t" r="r" b="b"/>
-              <a:pathLst>
-                <a:path w="17750118" h="13711966">
-                  <a:moveTo>
-                    <a:pt x="0" y="0"/>
-                  </a:moveTo>
-                  <a:lnTo>
-                    <a:pt x="17750118" y="0"/>
-                  </a:lnTo>
-                  <a:lnTo>
-                    <a:pt x="17750118" y="13711966"/>
-                  </a:lnTo>
-                  <a:lnTo>
-                    <a:pt x="0" y="13711966"/>
-                  </a:lnTo>
-                  <a:lnTo>
-                    <a:pt x="0" y="0"/>
-                  </a:lnTo>
-                  <a:close/>
-                </a:path>
-              </a:pathLst>
-            </a:custGeom>
-            <a:blipFill>
-              <a:blip r:embed="rId2"/>
-              <a:stretch>
-                <a:fillRect/>
-              </a:stretch>
-            </a:blipFill>
-          </p:spPr>
-        </p:sp>
-        <p:sp>
-          <p:nvSpPr>
-            <p:cNvPr id="4" name="Freeform 4"/>
-            <p:cNvSpPr/>
-            <p:nvPr/>
-          </p:nvSpPr>
-          <p:spPr>
-            <a:xfrm>
-              <a:off x="777253" y="616144"/>
-              <a:ext cx="9313341" cy="985065"/>
-            </a:xfrm>
-            <a:custGeom>
-              <a:avLst/>
-              <a:gdLst/>
-              <a:ahLst/>
-              <a:cxnLst/>
-              <a:rect l="l" t="t" r="r" b="b"/>
-              <a:pathLst>
-                <a:path w="9313341" h="985065">
-                  <a:moveTo>
-                    <a:pt x="0" y="0"/>
-                  </a:moveTo>
-                  <a:lnTo>
-                    <a:pt x="9313342" y="0"/>
-                  </a:lnTo>
-                  <a:lnTo>
-                    <a:pt x="9313342" y="985065"/>
-                  </a:lnTo>
-                  <a:lnTo>
-                    <a:pt x="0" y="985065"/>
-                  </a:lnTo>
-                  <a:lnTo>
-                    <a:pt x="0" y="0"/>
-                  </a:lnTo>
-                  <a:close/>
-                </a:path>
-              </a:pathLst>
-            </a:custGeom>
-            <a:blipFill>
-              <a:blip r:embed="rId3"/>
-              <a:stretch>
-                <a:fillRect/>
-              </a:stretch>
-            </a:blipFill>
-          </p:spPr>
-        </p:sp>
-        <p:sp>
-          <p:nvSpPr>
-            <p:cNvPr id="5" name="Freeform 5"/>
-            <p:cNvSpPr/>
-            <p:nvPr/>
-          </p:nvSpPr>
-          <p:spPr>
-            <a:xfrm>
-              <a:off x="777253" y="13401347"/>
-              <a:ext cx="16168531" cy="310619"/>
-            </a:xfrm>
-            <a:custGeom>
-              <a:avLst/>
-              <a:gdLst/>
-              <a:ahLst/>
-              <a:cxnLst/>
-              <a:rect l="l" t="t" r="r" b="b"/>
-              <a:pathLst>
-                <a:path w="16168531" h="310619">
-                  <a:moveTo>
-                    <a:pt x="0" y="0"/>
-                  </a:moveTo>
-                  <a:lnTo>
-                    <a:pt x="16168531" y="0"/>
-                  </a:lnTo>
-                  <a:lnTo>
-                    <a:pt x="16168531" y="310619"/>
-                  </a:lnTo>
-                  <a:lnTo>
-                    <a:pt x="0" y="310619"/>
-                  </a:lnTo>
-                  <a:lnTo>
-                    <a:pt x="0" y="0"/>
-                  </a:lnTo>
-                  <a:close/>
-                </a:path>
-              </a:pathLst>
-            </a:custGeom>
-            <a:blipFill>
-              <a:blip r:embed="rId4"/>
-              <a:stretch>
-                <a:fillRect/>
-              </a:stretch>
-            </a:blipFill>
-          </p:spPr>
-        </p:sp>
-      </p:grpSp>
-      <p:sp>
-        <p:nvSpPr>
-          <p:cNvPr id="6" name="TextBox 6"/>
-          <p:cNvSpPr txBox="1"/>
-          <p:nvPr/>
-        </p:nvSpPr>
-        <p:spPr>
-          <a:xfrm>
-            <a:off x="1230408" y="6421341"/>
-            <a:ext cx="609559" cy="645498"/>
-          </a:xfrm>
-          <a:prstGeom prst="rect">
-            <a:avLst/>
-          </a:prstGeom>
-        </p:spPr>
-        <p:txBody>
-          <a:bodyPr lIns="0" tIns="0" rIns="0" bIns="0" rtlCol="0" anchor="t">
-            <a:spAutoFit/>
-          </a:bodyPr>
-          <a:lstStyle/>
-          <a:p>
-            <a:pPr algn="ctr">
-              <a:lnSpc>
-                <a:spcPts val="2593"/>
-              </a:lnSpc>
-              <a:spcBef>
-                <a:spcPct val="0"/>
-              </a:spcBef>
-            </a:pPr>
-            <a:r>
-              <a:rPr lang="en-US" sz="1852" b="1">
-                <a:solidFill>
-                  <a:srgbClr val="000000"/>
-                </a:solidFill>
-                <a:latin typeface="Gilroy Bold"/>
-                <a:ea typeface="Gilroy Bold"/>
-                <a:cs typeface="Gilroy Bold"/>
-                <a:sym typeface="Gilroy Bold"/>
-              </a:rPr>
-              <a:t>Titulo</a:t>
-            </a:r>
-          </a:p>
-        </p:txBody>
-      </p:sp>
-      <p:sp>
-        <p:nvSpPr>
-          <p:cNvPr id="7" name="TextBox 7"/>
-          <p:cNvSpPr txBox="1"/>
-          <p:nvPr/>
-        </p:nvSpPr>
-        <p:spPr>
-          <a:xfrm>
-            <a:off x="1230406" y="6872240"/>
-            <a:ext cx="10302195" cy="1309333"/>
-          </a:xfrm>
-          <a:prstGeom prst="rect">
-            <a:avLst/>
-          </a:prstGeom>
-        </p:spPr>
-        <p:txBody>
-          <a:bodyPr lIns="0" tIns="0" rIns="0" bIns="0" rtlCol="0" anchor="t">
-            <a:spAutoFit/>
-          </a:bodyPr>
-          <a:lstStyle/>
-          <a:p>
-            <a:pPr algn="just">
-              <a:lnSpc>
-                <a:spcPts val="2593"/>
-              </a:lnSpc>
-            </a:pPr>
-            <a:r>
-              <a:rPr lang="en-US" sz="1852">
-                <a:solidFill>
-                  <a:srgbClr val="000000"/>
-                </a:solidFill>
-                <a:latin typeface="Gilroy"/>
-                <a:ea typeface="Gilroy"/>
-                <a:cs typeface="Gilroy"/>
-                <a:sym typeface="Gilroy"/>
-              </a:rPr>
-              <a:t>Lorem ipsum dolor sit amet, consectetur adipiscing elit, sed do eiusmod tempor incididunt ut labore et dolore magna aliqua. Ut enim ad minim veniam, quis nostrud exercitation ullamco laboris nisi ut aliquip ex ea commodo consequat. Duis aute irure dolor in reprehenderit in voluptate velit esse cillum.</a:t>
-            </a:r>
-          </a:p>
-        </p:txBody>
-      </p:sp>
-    </p:spTree>
-  </p:cSld>
-  <p:clrMapOvr>
-    <a:masterClrMapping/>
-  </p:clrMapOvr>
-</p:sld>
-</file>
-
-<file path=ppt/slides/slide4.xml><?xml version="1.0" encoding="utf-8"?>
+<file path=ppt/slides/slide5.xml><?xml version="1.0" encoding="utf-8"?>
 <p:sld xmlns:a="http://schemas.openxmlformats.org/drawingml/2006/main" xmlns:r="http://schemas.openxmlformats.org/officeDocument/2006/relationships" xmlns:p="http://schemas.openxmlformats.org/presentationml/2006/main">
   <p:cSld>
     <p:spTree>
@@ -4081,7 +5692,7 @@
               </a:spcBef>
             </a:pPr>
             <a:r>
-              <a:rPr lang="en-US" sz="6617" b="1">
+              <a:rPr lang="en-US" sz="6617" b="1" dirty="0">
                 <a:solidFill>
                   <a:srgbClr val="4B4B4B"/>
                 </a:solidFill>
@@ -4168,7 +5779,7 @@
               </a:lnSpc>
             </a:pPr>
             <a:r>
-              <a:rPr lang="en-US" sz="3971">
+              <a:rPr lang="en-US" sz="3971" dirty="0">
                 <a:solidFill>
                   <a:srgbClr val="7D2B39"/>
                 </a:solidFill>
@@ -4341,7 +5952,7 @@
 </p:sld>
 </file>
 
-<file path=ppt/slides/slide5.xml><?xml version="1.0" encoding="utf-8"?>
+<file path=ppt/slides/slide6.xml><?xml version="1.0" encoding="utf-8"?>
 <p:sld xmlns:a="http://schemas.openxmlformats.org/drawingml/2006/main" xmlns:r="http://schemas.openxmlformats.org/officeDocument/2006/relationships" xmlns:p="http://schemas.openxmlformats.org/presentationml/2006/main">
   <p:cSld>
     <p:spTree>
@@ -4511,91 +6122,6 @@
           </p:spPr>
         </p:sp>
       </p:grpSp>
-      <p:sp>
-        <p:nvSpPr>
-          <p:cNvPr id="6" name="TextBox 6"/>
-          <p:cNvSpPr txBox="1"/>
-          <p:nvPr/>
-        </p:nvSpPr>
-        <p:spPr>
-          <a:xfrm>
-            <a:off x="1230408" y="6421341"/>
-            <a:ext cx="609559" cy="645498"/>
-          </a:xfrm>
-          <a:prstGeom prst="rect">
-            <a:avLst/>
-          </a:prstGeom>
-        </p:spPr>
-        <p:txBody>
-          <a:bodyPr lIns="0" tIns="0" rIns="0" bIns="0" rtlCol="0" anchor="t">
-            <a:spAutoFit/>
-          </a:bodyPr>
-          <a:lstStyle/>
-          <a:p>
-            <a:pPr algn="ctr">
-              <a:lnSpc>
-                <a:spcPts val="2593"/>
-              </a:lnSpc>
-              <a:spcBef>
-                <a:spcPct val="0"/>
-              </a:spcBef>
-            </a:pPr>
-            <a:r>
-              <a:rPr lang="en-US" sz="1852" b="1">
-                <a:solidFill>
-                  <a:srgbClr val="000000"/>
-                </a:solidFill>
-                <a:latin typeface="Gilroy Bold"/>
-                <a:ea typeface="Gilroy Bold"/>
-                <a:cs typeface="Gilroy Bold"/>
-                <a:sym typeface="Gilroy Bold"/>
-              </a:rPr>
-              <a:t>Titulo</a:t>
-            </a:r>
-          </a:p>
-        </p:txBody>
-      </p:sp>
-      <p:sp>
-        <p:nvSpPr>
-          <p:cNvPr id="7" name="TextBox 7"/>
-          <p:cNvSpPr txBox="1"/>
-          <p:nvPr/>
-        </p:nvSpPr>
-        <p:spPr>
-          <a:xfrm>
-            <a:off x="1230406" y="6872240"/>
-            <a:ext cx="10302195" cy="1309333"/>
-          </a:xfrm>
-          <a:prstGeom prst="rect">
-            <a:avLst/>
-          </a:prstGeom>
-        </p:spPr>
-        <p:txBody>
-          <a:bodyPr lIns="0" tIns="0" rIns="0" bIns="0" rtlCol="0" anchor="t">
-            <a:spAutoFit/>
-          </a:bodyPr>
-          <a:lstStyle/>
-          <a:p>
-            <a:pPr algn="just">
-              <a:lnSpc>
-                <a:spcPts val="2593"/>
-              </a:lnSpc>
-            </a:pPr>
-            <a:r>
-              <a:rPr lang="en-US" sz="1852">
-                <a:solidFill>
-                  <a:srgbClr val="000000"/>
-                </a:solidFill>
-                <a:latin typeface="Gilroy"/>
-                <a:ea typeface="Gilroy"/>
-                <a:cs typeface="Gilroy"/>
-                <a:sym typeface="Gilroy"/>
-              </a:rPr>
-              <a:t>Lorem ipsum dolor sit amet, consectetur adipiscing elit, sed do eiusmod tempor incididunt ut labore et dolore magna aliqua. Ut enim ad minim veniam, quis nostrud exercitation ullamco laboris nisi ut aliquip ex ea commodo consequat. Duis aute irure dolor in reprehenderit in voluptate velit esse cillum.</a:t>
-            </a:r>
-          </a:p>
-        </p:txBody>
-      </p:sp>
     </p:spTree>
   </p:cSld>
   <p:clrMapOvr>
@@ -4604,7 +6130,7 @@
 </p:sld>
 </file>
 
-<file path=ppt/slides/slide6.xml><?xml version="1.0" encoding="utf-8"?>
+<file path=ppt/slides/slide7.xml><?xml version="1.0" encoding="utf-8"?>
 <p:sld xmlns:a="http://schemas.openxmlformats.org/drawingml/2006/main" xmlns:r="http://schemas.openxmlformats.org/officeDocument/2006/relationships" xmlns:p="http://schemas.openxmlformats.org/presentationml/2006/main">
   <p:cSld>
     <p:spTree>
@@ -4789,7 +6315,7 @@
               </a:spcBef>
             </a:pPr>
             <a:r>
-              <a:rPr lang="en-US" sz="6617" b="1">
+              <a:rPr lang="en-US" sz="6617" b="1" dirty="0">
                 <a:solidFill>
                   <a:srgbClr val="FFFFFF"/>
                 </a:solidFill>

</xml_diff>

<commit_message>
Ajuste pubtual de edición
</commit_message>
<xml_diff>
--- a/storage/templates/Dgdg Mesas de paz.pptx
+++ b/storage/templates/Dgdg Mesas de paz.pptx
@@ -356,7 +356,7 @@
             <a:fld id="{1D8BD707-D9CF-40AE-B4C6-C98DA3205C09}" type="datetimeFigureOut">
               <a:rPr lang="en-US" smtClean="0"/>
               <a:pPr/>
-              <a:t>4/6/2026</a:t>
+              <a:t>4/10/2026</a:t>
             </a:fld>
             <a:endParaRPr lang="en-US"/>
           </a:p>
@@ -521,7 +521,7 @@
             <a:fld id="{1D8BD707-D9CF-40AE-B4C6-C98DA3205C09}" type="datetimeFigureOut">
               <a:rPr lang="en-US" smtClean="0"/>
               <a:pPr/>
-              <a:t>4/6/2026</a:t>
+              <a:t>4/10/2026</a:t>
             </a:fld>
             <a:endParaRPr lang="en-US"/>
           </a:p>
@@ -696,7 +696,7 @@
             <a:fld id="{1D8BD707-D9CF-40AE-B4C6-C98DA3205C09}" type="datetimeFigureOut">
               <a:rPr lang="en-US" smtClean="0"/>
               <a:pPr/>
-              <a:t>4/6/2026</a:t>
+              <a:t>4/10/2026</a:t>
             </a:fld>
             <a:endParaRPr lang="en-US"/>
           </a:p>
@@ -861,7 +861,7 @@
             <a:fld id="{1D8BD707-D9CF-40AE-B4C6-C98DA3205C09}" type="datetimeFigureOut">
               <a:rPr lang="en-US" smtClean="0"/>
               <a:pPr/>
-              <a:t>4/6/2026</a:t>
+              <a:t>4/10/2026</a:t>
             </a:fld>
             <a:endParaRPr lang="en-US"/>
           </a:p>
@@ -1103,7 +1103,7 @@
             <a:fld id="{1D8BD707-D9CF-40AE-B4C6-C98DA3205C09}" type="datetimeFigureOut">
               <a:rPr lang="en-US" smtClean="0"/>
               <a:pPr/>
-              <a:t>4/6/2026</a:t>
+              <a:t>4/10/2026</a:t>
             </a:fld>
             <a:endParaRPr lang="en-US"/>
           </a:p>
@@ -1385,7 +1385,7 @@
             <a:fld id="{1D8BD707-D9CF-40AE-B4C6-C98DA3205C09}" type="datetimeFigureOut">
               <a:rPr lang="en-US" smtClean="0"/>
               <a:pPr/>
-              <a:t>4/6/2026</a:t>
+              <a:t>4/10/2026</a:t>
             </a:fld>
             <a:endParaRPr lang="en-US"/>
           </a:p>
@@ -1801,7 +1801,7 @@
             <a:fld id="{1D8BD707-D9CF-40AE-B4C6-C98DA3205C09}" type="datetimeFigureOut">
               <a:rPr lang="en-US" smtClean="0"/>
               <a:pPr/>
-              <a:t>4/6/2026</a:t>
+              <a:t>4/10/2026</a:t>
             </a:fld>
             <a:endParaRPr lang="en-US"/>
           </a:p>
@@ -1915,7 +1915,7 @@
             <a:fld id="{1D8BD707-D9CF-40AE-B4C6-C98DA3205C09}" type="datetimeFigureOut">
               <a:rPr lang="en-US" smtClean="0"/>
               <a:pPr/>
-              <a:t>4/6/2026</a:t>
+              <a:t>4/10/2026</a:t>
             </a:fld>
             <a:endParaRPr lang="en-US"/>
           </a:p>
@@ -2007,7 +2007,7 @@
             <a:fld id="{1D8BD707-D9CF-40AE-B4C6-C98DA3205C09}" type="datetimeFigureOut">
               <a:rPr lang="en-US" smtClean="0"/>
               <a:pPr/>
-              <a:t>4/6/2026</a:t>
+              <a:t>4/10/2026</a:t>
             </a:fld>
             <a:endParaRPr lang="en-US"/>
           </a:p>
@@ -2279,7 +2279,7 @@
             <a:fld id="{1D8BD707-D9CF-40AE-B4C6-C98DA3205C09}" type="datetimeFigureOut">
               <a:rPr lang="en-US" smtClean="0"/>
               <a:pPr/>
-              <a:t>4/6/2026</a:t>
+              <a:t>4/10/2026</a:t>
             </a:fld>
             <a:endParaRPr lang="en-US"/>
           </a:p>
@@ -2528,7 +2528,7 @@
             <a:fld id="{1D8BD707-D9CF-40AE-B4C6-C98DA3205C09}" type="datetimeFigureOut">
               <a:rPr lang="en-US" smtClean="0"/>
               <a:pPr/>
-              <a:t>4/6/2026</a:t>
+              <a:t>4/10/2026</a:t>
             </a:fld>
             <a:endParaRPr lang="en-US"/>
           </a:p>
@@ -2736,7 +2736,7 @@
             <a:fld id="{1D8BD707-D9CF-40AE-B4C6-C98DA3205C09}" type="datetimeFigureOut">
               <a:rPr lang="en-US" smtClean="0"/>
               <a:pPr/>
-              <a:t>4/6/2026</a:t>
+              <a:t>4/10/2026</a:t>
             </a:fld>
             <a:endParaRPr lang="en-US"/>
           </a:p>
@@ -11847,7 +11847,7 @@
         </p:nvSpPr>
         <p:spPr>
           <a:xfrm>
-            <a:off x="7509639" y="8180394"/>
+            <a:off x="7166059" y="8562546"/>
             <a:ext cx="4699523" cy="627736"/>
           </a:xfrm>
           <a:prstGeom prst="rect">
@@ -12056,7 +12056,7 @@
         </p:nvSpPr>
         <p:spPr>
           <a:xfrm>
-            <a:off x="6627787" y="2350407"/>
+            <a:off x="6172200" y="2672395"/>
             <a:ext cx="6463229" cy="627736"/>
           </a:xfrm>
           <a:prstGeom prst="rect">
@@ -15344,65 +15344,6 @@
       </p:sp>
       <p:sp>
         <p:nvSpPr>
-          <p:cNvPr id="11" name="TextBox 5">
-            <a:extLst>
-              <a:ext uri="{FF2B5EF4-FFF2-40B4-BE49-F238E27FC236}">
-                <a16:creationId xmlns:a16="http://schemas.microsoft.com/office/drawing/2014/main" id="{780C7D75-8A2B-4191-A7A3-CF5E7B6F2B87}"/>
-              </a:ext>
-            </a:extLst>
-          </p:cNvPr>
-          <p:cNvSpPr txBox="1"/>
-          <p:nvPr/>
-        </p:nvSpPr>
-        <p:spPr>
-          <a:xfrm>
-            <a:off x="7509639" y="8180394"/>
-            <a:ext cx="4699523" cy="627736"/>
-          </a:xfrm>
-          <a:prstGeom prst="rect">
-            <a:avLst/>
-          </a:prstGeom>
-        </p:spPr>
-        <p:txBody>
-          <a:bodyPr wrap="square" lIns="0" tIns="0" rIns="0" bIns="0" rtlCol="0" anchor="t">
-            <a:spAutoFit/>
-          </a:bodyPr>
-          <a:lstStyle/>
-          <a:p>
-            <a:pPr>
-              <a:lnSpc>
-                <a:spcPts val="5559"/>
-              </a:lnSpc>
-            </a:pPr>
-            <a:r>
-              <a:rPr lang="en-US" sz="2800" b="1" dirty="0">
-                <a:latin typeface="Gilroy"/>
-                <a:ea typeface="Gilroy"/>
-                <a:cs typeface="Gilroy"/>
-                <a:sym typeface="Gilroy"/>
-              </a:rPr>
-              <a:t>47.60% de </a:t>
-            </a:r>
-            <a:r>
-              <a:rPr lang="en-US" sz="2800" b="1" dirty="0" err="1">
-                <a:latin typeface="Gilroy"/>
-                <a:ea typeface="Gilroy"/>
-                <a:cs typeface="Gilroy"/>
-                <a:sym typeface="Gilroy"/>
-              </a:rPr>
-              <a:t>cumplimiento</a:t>
-            </a:r>
-            <a:endParaRPr lang="en-US" sz="2800" b="1" dirty="0">
-              <a:latin typeface="Gilroy"/>
-              <a:ea typeface="Gilroy"/>
-              <a:cs typeface="Gilroy"/>
-              <a:sym typeface="Gilroy"/>
-            </a:endParaRPr>
-          </a:p>
-        </p:txBody>
-      </p:sp>
-      <p:sp>
-        <p:nvSpPr>
           <p:cNvPr id="12" name="TextBox 3">
             <a:extLst>
               <a:ext uri="{FF2B5EF4-FFF2-40B4-BE49-F238E27FC236}">
@@ -15565,7 +15506,7 @@
         </p:nvSpPr>
         <p:spPr>
           <a:xfrm>
-            <a:off x="6627787" y="2350407"/>
+            <a:off x="6172200" y="2667304"/>
             <a:ext cx="6463229" cy="627736"/>
           </a:xfrm>
           <a:prstGeom prst="rect">
@@ -15619,6 +15560,65 @@
               </a:rPr>
               <a:t> de 2026</a:t>
             </a:r>
+          </a:p>
+        </p:txBody>
+      </p:sp>
+      <p:sp>
+        <p:nvSpPr>
+          <p:cNvPr id="15" name="TextBox 5">
+            <a:extLst>
+              <a:ext uri="{FF2B5EF4-FFF2-40B4-BE49-F238E27FC236}">
+                <a16:creationId xmlns:a16="http://schemas.microsoft.com/office/drawing/2014/main" id="{EF140913-7CA1-4A47-9403-48A1A59FFA94}"/>
+              </a:ext>
+            </a:extLst>
+          </p:cNvPr>
+          <p:cNvSpPr txBox="1"/>
+          <p:nvPr/>
+        </p:nvSpPr>
+        <p:spPr>
+          <a:xfrm>
+            <a:off x="7166059" y="8562546"/>
+            <a:ext cx="4699523" cy="627736"/>
+          </a:xfrm>
+          <a:prstGeom prst="rect">
+            <a:avLst/>
+          </a:prstGeom>
+        </p:spPr>
+        <p:txBody>
+          <a:bodyPr wrap="square" lIns="0" tIns="0" rIns="0" bIns="0" rtlCol="0" anchor="t">
+            <a:spAutoFit/>
+          </a:bodyPr>
+          <a:lstStyle/>
+          <a:p>
+            <a:pPr>
+              <a:lnSpc>
+                <a:spcPts val="5559"/>
+              </a:lnSpc>
+            </a:pPr>
+            <a:r>
+              <a:rPr lang="en-US" sz="2800" b="1" dirty="0">
+                <a:latin typeface="Gilroy"/>
+                <a:ea typeface="Gilroy"/>
+                <a:cs typeface="Gilroy"/>
+                <a:sym typeface="Gilroy"/>
+              </a:rPr>
+              <a:t>47.60% de </a:t>
+            </a:r>
+            <a:r>
+              <a:rPr lang="en-US" sz="2800" b="1" dirty="0" err="1">
+                <a:latin typeface="Gilroy"/>
+                <a:ea typeface="Gilroy"/>
+                <a:cs typeface="Gilroy"/>
+                <a:sym typeface="Gilroy"/>
+              </a:rPr>
+              <a:t>cumplimiento</a:t>
+            </a:r>
+            <a:endParaRPr lang="en-US" sz="2800" b="1" dirty="0">
+              <a:latin typeface="Gilroy"/>
+              <a:ea typeface="Gilroy"/>
+              <a:cs typeface="Gilroy"/>
+              <a:sym typeface="Gilroy"/>
+            </a:endParaRPr>
           </a:p>
         </p:txBody>
       </p:sp>

</xml_diff>